<commit_message>
Playbook: incluye Las Colinas en los textos de marca
Co-Authored-By: Claude Opus 5.5 <noreply@anthropic.com>
Claude-Session: https://claude.ai/code/session_0111i7vn9WWo4QxCQbucWbrF
</commit_message>
<xml_diff>
--- a/playbook/salida/Playbook_Comercial_Cremacion_Vangrupo.pptx
+++ b/playbook/salida/Playbook_Comercial_Cremacion_Vangrupo.pptx
@@ -3984,7 +3984,7 @@
         <p:spPr>
           <a:xfrm>
             <a:off x="548640" y="6446520"/>
-            <a:ext cx="8229600" cy="274320"/>
+            <a:ext cx="10180015" cy="274320"/>
           </a:xfrm>
           <a:prstGeom prst="rect">
             <a:avLst/>
@@ -4012,7 +4012,7 @@
                 </a:solidFill>
                 <a:latin typeface="Montserrat"/>
               </a:rPr>
-              <a:t>Playbook Comercial  ·  La Auxiliadora · Hogar de las Memorias · Vangrupo</a:t>
+              <a:t>Playbook Comercial  ·  La Auxiliadora · Hogar de las Memorias · Las Colinas · Vangrupo</a:t>
             </a:r>
           </a:p>
         </p:txBody>
@@ -4290,7 +4290,7 @@
         <p:spPr>
           <a:xfrm>
             <a:off x="548640" y="6446520"/>
-            <a:ext cx="8229600" cy="274320"/>
+            <a:ext cx="10180015" cy="274320"/>
           </a:xfrm>
           <a:prstGeom prst="rect">
             <a:avLst/>
@@ -4318,7 +4318,7 @@
                 </a:solidFill>
                 <a:latin typeface="Montserrat"/>
               </a:rPr>
-              <a:t>Playbook Comercial  ·  La Auxiliadora · Hogar de las Memorias · Vangrupo</a:t>
+              <a:t>Playbook Comercial  ·  La Auxiliadora · Hogar de las Memorias · Las Colinas · Vangrupo</a:t>
             </a:r>
           </a:p>
         </p:txBody>
@@ -5128,7 +5128,7 @@
         <p:spPr>
           <a:xfrm>
             <a:off x="548640" y="6446520"/>
-            <a:ext cx="8229600" cy="274320"/>
+            <a:ext cx="10180015" cy="274320"/>
           </a:xfrm>
           <a:prstGeom prst="rect">
             <a:avLst/>
@@ -5156,7 +5156,7 @@
                 </a:solidFill>
                 <a:latin typeface="Montserrat"/>
               </a:rPr>
-              <a:t>Playbook Comercial  ·  La Auxiliadora · Hogar de las Memorias · Vangrupo</a:t>
+              <a:t>Playbook Comercial  ·  La Auxiliadora · Hogar de las Memorias · Las Colinas · Vangrupo</a:t>
             </a:r>
           </a:p>
         </p:txBody>
@@ -6145,7 +6145,7 @@
         <p:spPr>
           <a:xfrm>
             <a:off x="548640" y="6446520"/>
-            <a:ext cx="8229600" cy="274320"/>
+            <a:ext cx="10180015" cy="274320"/>
           </a:xfrm>
           <a:prstGeom prst="rect">
             <a:avLst/>
@@ -6173,7 +6173,7 @@
                 </a:solidFill>
                 <a:latin typeface="Montserrat"/>
               </a:rPr>
-              <a:t>Playbook Comercial  ·  La Auxiliadora · Hogar de las Memorias · Vangrupo</a:t>
+              <a:t>Playbook Comercial  ·  La Auxiliadora · Hogar de las Memorias · Las Colinas · Vangrupo</a:t>
             </a:r>
           </a:p>
         </p:txBody>
@@ -7264,7 +7264,7 @@
         <p:spPr>
           <a:xfrm>
             <a:off x="548640" y="6446520"/>
-            <a:ext cx="8229600" cy="274320"/>
+            <a:ext cx="10180015" cy="274320"/>
           </a:xfrm>
           <a:prstGeom prst="rect">
             <a:avLst/>
@@ -7292,7 +7292,7 @@
                 </a:solidFill>
                 <a:latin typeface="Montserrat"/>
               </a:rPr>
-              <a:t>Playbook Comercial  ·  La Auxiliadora · Hogar de las Memorias · Vangrupo</a:t>
+              <a:t>Playbook Comercial  ·  La Auxiliadora · Hogar de las Memorias · Las Colinas · Vangrupo</a:t>
             </a:r>
           </a:p>
         </p:txBody>
@@ -8253,7 +8253,7 @@
         <p:spPr>
           <a:xfrm>
             <a:off x="548640" y="6446520"/>
-            <a:ext cx="8229600" cy="274320"/>
+            <a:ext cx="10180015" cy="274320"/>
           </a:xfrm>
           <a:prstGeom prst="rect">
             <a:avLst/>
@@ -8281,7 +8281,7 @@
                 </a:solidFill>
                 <a:latin typeface="Montserrat"/>
               </a:rPr>
-              <a:t>Playbook Comercial  ·  La Auxiliadora · Hogar de las Memorias · Vangrupo</a:t>
+              <a:t>Playbook Comercial  ·  La Auxiliadora · Hogar de las Memorias · Las Colinas · Vangrupo</a:t>
             </a:r>
           </a:p>
         </p:txBody>
@@ -9372,7 +9372,7 @@
         <p:spPr>
           <a:xfrm>
             <a:off x="548640" y="6446520"/>
-            <a:ext cx="8229600" cy="274320"/>
+            <a:ext cx="10180015" cy="274320"/>
           </a:xfrm>
           <a:prstGeom prst="rect">
             <a:avLst/>
@@ -9400,7 +9400,7 @@
                 </a:solidFill>
                 <a:latin typeface="Montserrat"/>
               </a:rPr>
-              <a:t>Playbook Comercial  ·  La Auxiliadora · Hogar de las Memorias · Vangrupo</a:t>
+              <a:t>Playbook Comercial  ·  La Auxiliadora · Hogar de las Memorias · Las Colinas · Vangrupo</a:t>
             </a:r>
           </a:p>
         </p:txBody>
@@ -10361,7 +10361,7 @@
         <p:spPr>
           <a:xfrm>
             <a:off x="548640" y="6446520"/>
-            <a:ext cx="8229600" cy="274320"/>
+            <a:ext cx="10180015" cy="274320"/>
           </a:xfrm>
           <a:prstGeom prst="rect">
             <a:avLst/>
@@ -10389,7 +10389,7 @@
                 </a:solidFill>
                 <a:latin typeface="Montserrat"/>
               </a:rPr>
-              <a:t>Playbook Comercial  ·  La Auxiliadora · Hogar de las Memorias · Vangrupo</a:t>
+              <a:t>Playbook Comercial  ·  La Auxiliadora · Hogar de las Memorias · Las Colinas · Vangrupo</a:t>
             </a:r>
           </a:p>
         </p:txBody>
@@ -11480,7 +11480,7 @@
         <p:spPr>
           <a:xfrm>
             <a:off x="548640" y="6446520"/>
-            <a:ext cx="8229600" cy="274320"/>
+            <a:ext cx="10180015" cy="274320"/>
           </a:xfrm>
           <a:prstGeom prst="rect">
             <a:avLst/>
@@ -11508,7 +11508,7 @@
                 </a:solidFill>
                 <a:latin typeface="Montserrat"/>
               </a:rPr>
-              <a:t>Playbook Comercial  ·  La Auxiliadora · Hogar de las Memorias · Vangrupo</a:t>
+              <a:t>Playbook Comercial  ·  La Auxiliadora · Hogar de las Memorias · Las Colinas · Vangrupo</a:t>
             </a:r>
           </a:p>
         </p:txBody>
@@ -12497,7 +12497,7 @@
         <p:spPr>
           <a:xfrm>
             <a:off x="548640" y="6446520"/>
-            <a:ext cx="8229600" cy="274320"/>
+            <a:ext cx="10180015" cy="274320"/>
           </a:xfrm>
           <a:prstGeom prst="rect">
             <a:avLst/>
@@ -12525,7 +12525,7 @@
                 </a:solidFill>
                 <a:latin typeface="Montserrat"/>
               </a:rPr>
-              <a:t>Playbook Comercial  ·  La Auxiliadora · Hogar de las Memorias · Vangrupo</a:t>
+              <a:t>Playbook Comercial  ·  La Auxiliadora · Hogar de las Memorias · Las Colinas · Vangrupo</a:t>
             </a:r>
           </a:p>
         </p:txBody>
@@ -14152,7 +14152,7 @@
         <p:spPr>
           <a:xfrm>
             <a:off x="548640" y="6446520"/>
-            <a:ext cx="8229600" cy="274320"/>
+            <a:ext cx="10180015" cy="274320"/>
           </a:xfrm>
           <a:prstGeom prst="rect">
             <a:avLst/>
@@ -14180,7 +14180,7 @@
                 </a:solidFill>
                 <a:latin typeface="Montserrat"/>
               </a:rPr>
-              <a:t>Playbook Comercial  ·  La Auxiliadora · Hogar de las Memorias · Vangrupo</a:t>
+              <a:t>Playbook Comercial  ·  La Auxiliadora · Hogar de las Memorias · Las Colinas · Vangrupo</a:t>
             </a:r>
           </a:p>
         </p:txBody>
@@ -15271,7 +15271,7 @@
         <p:spPr>
           <a:xfrm>
             <a:off x="548640" y="6446520"/>
-            <a:ext cx="8229600" cy="274320"/>
+            <a:ext cx="10180015" cy="274320"/>
           </a:xfrm>
           <a:prstGeom prst="rect">
             <a:avLst/>
@@ -15299,7 +15299,7 @@
                 </a:solidFill>
                 <a:latin typeface="Montserrat"/>
               </a:rPr>
-              <a:t>Playbook Comercial  ·  La Auxiliadora · Hogar de las Memorias · Vangrupo</a:t>
+              <a:t>Playbook Comercial  ·  La Auxiliadora · Hogar de las Memorias · Las Colinas · Vangrupo</a:t>
             </a:r>
           </a:p>
         </p:txBody>
@@ -15577,7 +15577,7 @@
         <p:spPr>
           <a:xfrm>
             <a:off x="548640" y="6446520"/>
-            <a:ext cx="8229600" cy="274320"/>
+            <a:ext cx="10180015" cy="274320"/>
           </a:xfrm>
           <a:prstGeom prst="rect">
             <a:avLst/>
@@ -15605,7 +15605,7 @@
                 </a:solidFill>
                 <a:latin typeface="Montserrat"/>
               </a:rPr>
-              <a:t>Playbook Comercial  ·  La Auxiliadora · Hogar de las Memorias · Vangrupo</a:t>
+              <a:t>Playbook Comercial  ·  La Auxiliadora · Hogar de las Memorias · Las Colinas · Vangrupo</a:t>
             </a:r>
           </a:p>
         </p:txBody>
@@ -16594,7 +16594,7 @@
         <p:spPr>
           <a:xfrm>
             <a:off x="548640" y="6446520"/>
-            <a:ext cx="8229600" cy="274320"/>
+            <a:ext cx="10180015" cy="274320"/>
           </a:xfrm>
           <a:prstGeom prst="rect">
             <a:avLst/>
@@ -16622,7 +16622,7 @@
                 </a:solidFill>
                 <a:latin typeface="Montserrat"/>
               </a:rPr>
-              <a:t>Playbook Comercial  ·  La Auxiliadora · Hogar de las Memorias · Vangrupo</a:t>
+              <a:t>Playbook Comercial  ·  La Auxiliadora · Hogar de las Memorias · Las Colinas · Vangrupo</a:t>
             </a:r>
           </a:p>
         </p:txBody>
@@ -17713,7 +17713,7 @@
         <p:spPr>
           <a:xfrm>
             <a:off x="548640" y="6446520"/>
-            <a:ext cx="8229600" cy="274320"/>
+            <a:ext cx="10180015" cy="274320"/>
           </a:xfrm>
           <a:prstGeom prst="rect">
             <a:avLst/>
@@ -17741,7 +17741,7 @@
                 </a:solidFill>
                 <a:latin typeface="Montserrat"/>
               </a:rPr>
-              <a:t>Playbook Comercial  ·  La Auxiliadora · Hogar de las Memorias · Vangrupo</a:t>
+              <a:t>Playbook Comercial  ·  La Auxiliadora · Hogar de las Memorias · Las Colinas · Vangrupo</a:t>
             </a:r>
           </a:p>
         </p:txBody>
@@ -18646,7 +18646,7 @@
         <p:spPr>
           <a:xfrm>
             <a:off x="548640" y="6446520"/>
-            <a:ext cx="8229600" cy="274320"/>
+            <a:ext cx="10180015" cy="274320"/>
           </a:xfrm>
           <a:prstGeom prst="rect">
             <a:avLst/>
@@ -18674,7 +18674,7 @@
                 </a:solidFill>
                 <a:latin typeface="Montserrat"/>
               </a:rPr>
-              <a:t>Playbook Comercial  ·  La Auxiliadora · Hogar de las Memorias · Vangrupo</a:t>
+              <a:t>Playbook Comercial  ·  La Auxiliadora · Hogar de las Memorias · Las Colinas · Vangrupo</a:t>
             </a:r>
           </a:p>
         </p:txBody>
@@ -18926,7 +18926,7 @@
         <p:spPr>
           <a:xfrm>
             <a:off x="548640" y="6446520"/>
-            <a:ext cx="8229600" cy="274320"/>
+            <a:ext cx="10180015" cy="274320"/>
           </a:xfrm>
           <a:prstGeom prst="rect">
             <a:avLst/>
@@ -18954,7 +18954,7 @@
                 </a:solidFill>
                 <a:latin typeface="Montserrat"/>
               </a:rPr>
-              <a:t>Playbook Comercial  ·  La Auxiliadora · Hogar de las Memorias · Vangrupo</a:t>
+              <a:t>Playbook Comercial  ·  La Auxiliadora · Hogar de las Memorias · Las Colinas · Vangrupo</a:t>
             </a:r>
           </a:p>
         </p:txBody>
@@ -19232,7 +19232,7 @@
         <p:spPr>
           <a:xfrm>
             <a:off x="548640" y="6446520"/>
-            <a:ext cx="8229600" cy="274320"/>
+            <a:ext cx="10180015" cy="274320"/>
           </a:xfrm>
           <a:prstGeom prst="rect">
             <a:avLst/>
@@ -19260,7 +19260,7 @@
                 </a:solidFill>
                 <a:latin typeface="Montserrat"/>
               </a:rPr>
-              <a:t>Playbook Comercial  ·  La Auxiliadora · Hogar de las Memorias · Vangrupo</a:t>
+              <a:t>Playbook Comercial  ·  La Auxiliadora · Hogar de las Memorias · Las Colinas · Vangrupo</a:t>
             </a:r>
           </a:p>
         </p:txBody>
@@ -20370,7 +20370,7 @@
         <p:spPr>
           <a:xfrm>
             <a:off x="548640" y="6446520"/>
-            <a:ext cx="8229600" cy="274320"/>
+            <a:ext cx="10180015" cy="274320"/>
           </a:xfrm>
           <a:prstGeom prst="rect">
             <a:avLst/>
@@ -20398,7 +20398,7 @@
                 </a:solidFill>
                 <a:latin typeface="Montserrat"/>
               </a:rPr>
-              <a:t>Playbook Comercial  ·  La Auxiliadora · Hogar de las Memorias · Vangrupo</a:t>
+              <a:t>Playbook Comercial  ·  La Auxiliadora · Hogar de las Memorias · Las Colinas · Vangrupo</a:t>
             </a:r>
           </a:p>
         </p:txBody>
@@ -21508,7 +21508,7 @@
         <p:spPr>
           <a:xfrm>
             <a:off x="548640" y="6446520"/>
-            <a:ext cx="8229600" cy="274320"/>
+            <a:ext cx="10180015" cy="274320"/>
           </a:xfrm>
           <a:prstGeom prst="rect">
             <a:avLst/>
@@ -21536,7 +21536,7 @@
                 </a:solidFill>
                 <a:latin typeface="Montserrat"/>
               </a:rPr>
-              <a:t>Playbook Comercial  ·  La Auxiliadora · Hogar de las Memorias · Vangrupo</a:t>
+              <a:t>Playbook Comercial  ·  La Auxiliadora · Hogar de las Memorias · Las Colinas · Vangrupo</a:t>
             </a:r>
           </a:p>
         </p:txBody>
@@ -22646,7 +22646,7 @@
         <p:spPr>
           <a:xfrm>
             <a:off x="548640" y="6446520"/>
-            <a:ext cx="8229600" cy="274320"/>
+            <a:ext cx="10180015" cy="274320"/>
           </a:xfrm>
           <a:prstGeom prst="rect">
             <a:avLst/>
@@ -22674,7 +22674,7 @@
                 </a:solidFill>
                 <a:latin typeface="Montserrat"/>
               </a:rPr>
-              <a:t>Playbook Comercial  ·  La Auxiliadora · Hogar de las Memorias · Vangrupo</a:t>
+              <a:t>Playbook Comercial  ·  La Auxiliadora · Hogar de las Memorias · Las Colinas · Vangrupo</a:t>
             </a:r>
           </a:p>
         </p:txBody>
@@ -22926,7 +22926,7 @@
         <p:spPr>
           <a:xfrm>
             <a:off x="548640" y="6446520"/>
-            <a:ext cx="8229600" cy="274320"/>
+            <a:ext cx="10180015" cy="274320"/>
           </a:xfrm>
           <a:prstGeom prst="rect">
             <a:avLst/>
@@ -22954,7 +22954,7 @@
                 </a:solidFill>
                 <a:latin typeface="Montserrat"/>
               </a:rPr>
-              <a:t>Playbook Comercial  ·  La Auxiliadora · Hogar de las Memorias · Vangrupo</a:t>
+              <a:t>Playbook Comercial  ·  La Auxiliadora · Hogar de las Memorias · Las Colinas · Vangrupo</a:t>
             </a:r>
           </a:p>
         </p:txBody>
@@ -23936,7 +23936,7 @@
                 </a:solidFill>
                 <a:latin typeface="Montserrat"/>
               </a:rPr>
-              <a:t>Somos La Auxiliadora y Hogar de las Memorias, empresas de Vangrupo con trayectoria en El Salvador. El contrato es transparente y puede visitar el jardín cuando quiera.</a:t>
+              <a:t>Somos La Auxiliadora, Hogar de las Memorias y Las Colinas, empresas de Vangrupo con trayectoria en El Salvador. El contrato es transparente y puede visitar el jardín cuando quiera.</a:t>
             </a:r>
           </a:p>
         </p:txBody>
@@ -24064,7 +24064,7 @@
         <p:spPr>
           <a:xfrm>
             <a:off x="548640" y="6446520"/>
-            <a:ext cx="8229600" cy="274320"/>
+            <a:ext cx="10180015" cy="274320"/>
           </a:xfrm>
           <a:prstGeom prst="rect">
             <a:avLst/>
@@ -24092,7 +24092,7 @@
                 </a:solidFill>
                 <a:latin typeface="Montserrat"/>
               </a:rPr>
-              <a:t>Playbook Comercial  ·  La Auxiliadora · Hogar de las Memorias · Vangrupo</a:t>
+              <a:t>Playbook Comercial  ·  La Auxiliadora · Hogar de las Memorias · Las Colinas · Vangrupo</a:t>
             </a:r>
           </a:p>
         </p:txBody>
@@ -24344,7 +24344,7 @@
         <p:spPr>
           <a:xfrm>
             <a:off x="548640" y="6446520"/>
-            <a:ext cx="8229600" cy="274320"/>
+            <a:ext cx="10180015" cy="274320"/>
           </a:xfrm>
           <a:prstGeom prst="rect">
             <a:avLst/>
@@ -24372,7 +24372,7 @@
                 </a:solidFill>
                 <a:latin typeface="Montserrat"/>
               </a:rPr>
-              <a:t>Playbook Comercial  ·  La Auxiliadora · Hogar de las Memorias · Vangrupo</a:t>
+              <a:t>Playbook Comercial  ·  La Auxiliadora · Hogar de las Memorias · Las Colinas · Vangrupo</a:t>
             </a:r>
           </a:p>
         </p:txBody>
@@ -25576,7 +25576,7 @@
         <p:spPr>
           <a:xfrm>
             <a:off x="548640" y="6446520"/>
-            <a:ext cx="8229600" cy="274320"/>
+            <a:ext cx="10180015" cy="274320"/>
           </a:xfrm>
           <a:prstGeom prst="rect">
             <a:avLst/>
@@ -25604,7 +25604,7 @@
                 </a:solidFill>
                 <a:latin typeface="Montserrat"/>
               </a:rPr>
-              <a:t>Playbook Comercial  ·  La Auxiliadora · Hogar de las Memorias · Vangrupo</a:t>
+              <a:t>Playbook Comercial  ·  La Auxiliadora · Hogar de las Memorias · Las Colinas · Vangrupo</a:t>
             </a:r>
           </a:p>
         </p:txBody>
@@ -26252,7 +26252,7 @@
         <p:spPr>
           <a:xfrm>
             <a:off x="548640" y="6446520"/>
-            <a:ext cx="8229600" cy="274320"/>
+            <a:ext cx="10180015" cy="274320"/>
           </a:xfrm>
           <a:prstGeom prst="rect">
             <a:avLst/>
@@ -26280,7 +26280,7 @@
                 </a:solidFill>
                 <a:latin typeface="Montserrat"/>
               </a:rPr>
-              <a:t>Playbook Comercial  ·  La Auxiliadora · Hogar de las Memorias · Vangrupo</a:t>
+              <a:t>Playbook Comercial  ·  La Auxiliadora · Hogar de las Memorias · Las Colinas · Vangrupo</a:t>
             </a:r>
           </a:p>
         </p:txBody>
@@ -26532,7 +26532,7 @@
         <p:spPr>
           <a:xfrm>
             <a:off x="548640" y="6446520"/>
-            <a:ext cx="8229600" cy="274320"/>
+            <a:ext cx="10180015" cy="274320"/>
           </a:xfrm>
           <a:prstGeom prst="rect">
             <a:avLst/>
@@ -26560,7 +26560,7 @@
                 </a:solidFill>
                 <a:latin typeface="Montserrat"/>
               </a:rPr>
-              <a:t>Playbook Comercial  ·  La Auxiliadora · Hogar de las Memorias · Vangrupo</a:t>
+              <a:t>Playbook Comercial  ·  La Auxiliadora · Hogar de las Memorias · Las Colinas · Vangrupo</a:t>
             </a:r>
           </a:p>
         </p:txBody>
@@ -27199,7 +27199,7 @@
         <p:spPr>
           <a:xfrm>
             <a:off x="548640" y="6446520"/>
-            <a:ext cx="8229600" cy="274320"/>
+            <a:ext cx="10180015" cy="274320"/>
           </a:xfrm>
           <a:prstGeom prst="rect">
             <a:avLst/>
@@ -27227,7 +27227,7 @@
                 </a:solidFill>
                 <a:latin typeface="Montserrat"/>
               </a:rPr>
-              <a:t>Playbook Comercial  ·  La Auxiliadora · Hogar de las Memorias · Vangrupo</a:t>
+              <a:t>Playbook Comercial  ·  La Auxiliadora · Hogar de las Memorias · Las Colinas · Vangrupo</a:t>
             </a:r>
           </a:p>
         </p:txBody>
@@ -28406,7 +28406,7 @@
         <p:spPr>
           <a:xfrm>
             <a:off x="548640" y="6446520"/>
-            <a:ext cx="8229600" cy="274320"/>
+            <a:ext cx="10180015" cy="274320"/>
           </a:xfrm>
           <a:prstGeom prst="rect">
             <a:avLst/>
@@ -28434,7 +28434,7 @@
                 </a:solidFill>
                 <a:latin typeface="Montserrat"/>
               </a:rPr>
-              <a:t>Playbook Comercial  ·  La Auxiliadora · Hogar de las Memorias · Vangrupo</a:t>
+              <a:t>Playbook Comercial  ·  La Auxiliadora · Hogar de las Memorias · Las Colinas · Vangrupo</a:t>
             </a:r>
           </a:p>
         </p:txBody>
@@ -28686,7 +28686,7 @@
         <p:spPr>
           <a:xfrm>
             <a:off x="548640" y="6446520"/>
-            <a:ext cx="8229600" cy="274320"/>
+            <a:ext cx="10180015" cy="274320"/>
           </a:xfrm>
           <a:prstGeom prst="rect">
             <a:avLst/>
@@ -28714,7 +28714,7 @@
                 </a:solidFill>
                 <a:latin typeface="Montserrat"/>
               </a:rPr>
-              <a:t>Playbook Comercial  ·  La Auxiliadora · Hogar de las Memorias · Vangrupo</a:t>
+              <a:t>Playbook Comercial  ·  La Auxiliadora · Hogar de las Memorias · Las Colinas · Vangrupo</a:t>
             </a:r>
           </a:p>
         </p:txBody>
@@ -29990,7 +29990,7 @@
         <p:spPr>
           <a:xfrm>
             <a:off x="548640" y="6446520"/>
-            <a:ext cx="8229600" cy="274320"/>
+            <a:ext cx="10180015" cy="274320"/>
           </a:xfrm>
           <a:prstGeom prst="rect">
             <a:avLst/>
@@ -30018,7 +30018,7 @@
                 </a:solidFill>
                 <a:latin typeface="Montserrat"/>
               </a:rPr>
-              <a:t>Playbook Comercial  ·  La Auxiliadora · Hogar de las Memorias · Vangrupo</a:t>
+              <a:t>Playbook Comercial  ·  La Auxiliadora · Hogar de las Memorias · Las Colinas · Vangrupo</a:t>
             </a:r>
           </a:p>
         </p:txBody>
@@ -30258,7 +30258,7 @@
                 </a:solidFill>
                 <a:latin typeface="Montserrat"/>
               </a:rPr>
-              <a:t>La Auxiliadora · Hogar de las Memorias · Vangrupo</a:t>
+              <a:t>La Auxiliadora · Hogar de las Memorias · Las Colinas · Vangrupo</a:t>
             </a:r>
           </a:p>
         </p:txBody>
@@ -30498,7 +30498,7 @@
                 </a:solidFill>
                 <a:latin typeface="Montserrat"/>
               </a:rPr>
-              <a:t>En La Auxiliadora y Hogar de las Memorias, empresas de Vangrupo, no vendemos nichos, parcelas ni servicios: acompañamos a las familias salvadoreñas a honrar la memoria de quienes aman. La cremación es una decisión cada vez más elegida, y nuestros nuevos jardines de cenizas responden a una pregunta que muchas familias se hacen y pocas se atreven a decir: «¿y después de la cremación, dónde las visitamos?».</a:t>
+              <a:t>En La Auxiliadora, Hogar de las Memorias y Parque Memorial Las Colinas, empresas de Vangrupo, no vendemos nichos, parcelas ni servicios: acompañamos a las familias salvadoreñas a honrar la memoria de quienes aman. La cremación es una decisión cada vez más elegida, y nuestros nuevos jardines de cenizas responden a una pregunta que muchas familias se hacen y pocas se atreven a decir: «¿y después de la cremación, dónde las visitamos?».</a:t>
             </a:r>
           </a:p>
         </p:txBody>
@@ -31295,7 +31295,7 @@
         <p:spPr>
           <a:xfrm>
             <a:off x="548640" y="6446520"/>
-            <a:ext cx="8229600" cy="274320"/>
+            <a:ext cx="10180015" cy="274320"/>
           </a:xfrm>
           <a:prstGeom prst="rect">
             <a:avLst/>
@@ -31323,7 +31323,7 @@
                 </a:solidFill>
                 <a:latin typeface="Montserrat"/>
               </a:rPr>
-              <a:t>Playbook Comercial  ·  La Auxiliadora · Hogar de las Memorias · Vangrupo</a:t>
+              <a:t>Playbook Comercial  ·  La Auxiliadora · Hogar de las Memorias · Las Colinas · Vangrupo</a:t>
             </a:r>
           </a:p>
         </p:txBody>
@@ -31601,7 +31601,7 @@
         <p:spPr>
           <a:xfrm>
             <a:off x="548640" y="6446520"/>
-            <a:ext cx="8229600" cy="274320"/>
+            <a:ext cx="10180015" cy="274320"/>
           </a:xfrm>
           <a:prstGeom prst="rect">
             <a:avLst/>
@@ -31629,7 +31629,7 @@
                 </a:solidFill>
                 <a:latin typeface="Montserrat"/>
               </a:rPr>
-              <a:t>Playbook Comercial  ·  La Auxiliadora · Hogar de las Memorias · Vangrupo</a:t>
+              <a:t>Playbook Comercial  ·  La Auxiliadora · Hogar de las Memorias · Las Colinas · Vangrupo</a:t>
             </a:r>
           </a:p>
         </p:txBody>
@@ -32584,7 +32584,7 @@
         <p:spPr>
           <a:xfrm>
             <a:off x="548640" y="6446520"/>
-            <a:ext cx="8229600" cy="274320"/>
+            <a:ext cx="10180015" cy="274320"/>
           </a:xfrm>
           <a:prstGeom prst="rect">
             <a:avLst/>
@@ -32612,7 +32612,7 @@
                 </a:solidFill>
                 <a:latin typeface="Montserrat"/>
               </a:rPr>
-              <a:t>Playbook Comercial  ·  La Auxiliadora · Hogar de las Memorias · Vangrupo</a:t>
+              <a:t>Playbook Comercial  ·  La Auxiliadora · Hogar de las Memorias · Las Colinas · Vangrupo</a:t>
             </a:r>
           </a:p>
         </p:txBody>
@@ -32864,7 +32864,7 @@
         <p:spPr>
           <a:xfrm>
             <a:off x="548640" y="6446520"/>
-            <a:ext cx="8229600" cy="274320"/>
+            <a:ext cx="10180015" cy="274320"/>
           </a:xfrm>
           <a:prstGeom prst="rect">
             <a:avLst/>
@@ -32892,7 +32892,7 @@
                 </a:solidFill>
                 <a:latin typeface="Montserrat"/>
               </a:rPr>
-              <a:t>Playbook Comercial  ·  La Auxiliadora · Hogar de las Memorias · Vangrupo</a:t>
+              <a:t>Playbook Comercial  ·  La Auxiliadora · Hogar de las Memorias · Las Colinas · Vangrupo</a:t>
             </a:r>
           </a:p>
         </p:txBody>
@@ -34563,7 +34563,7 @@
         <p:spPr>
           <a:xfrm>
             <a:off x="548640" y="6446520"/>
-            <a:ext cx="8229600" cy="274320"/>
+            <a:ext cx="10180015" cy="274320"/>
           </a:xfrm>
           <a:prstGeom prst="rect">
             <a:avLst/>
@@ -34591,7 +34591,7 @@
                 </a:solidFill>
                 <a:latin typeface="Montserrat"/>
               </a:rPr>
-              <a:t>Playbook Comercial  ·  La Auxiliadora · Hogar de las Memorias · Vangrupo</a:t>
+              <a:t>Playbook Comercial  ·  La Auxiliadora · Hogar de las Memorias · Las Colinas · Vangrupo</a:t>
             </a:r>
           </a:p>
         </p:txBody>
@@ -34843,7 +34843,7 @@
         <p:spPr>
           <a:xfrm>
             <a:off x="548640" y="6446520"/>
-            <a:ext cx="8229600" cy="274320"/>
+            <a:ext cx="10180015" cy="274320"/>
           </a:xfrm>
           <a:prstGeom prst="rect">
             <a:avLst/>
@@ -34871,7 +34871,7 @@
                 </a:solidFill>
                 <a:latin typeface="Montserrat"/>
               </a:rPr>
-              <a:t>Playbook Comercial  ·  La Auxiliadora · Hogar de las Memorias · Vangrupo</a:t>
+              <a:t>Playbook Comercial  ·  La Auxiliadora · Hogar de las Memorias · Las Colinas · Vangrupo</a:t>
             </a:r>
           </a:p>
         </p:txBody>

</xml_diff>

<commit_message>
Quita los valores de cuota mensual: pago en hasta 120 meses con intereses
- Ficha técnica: sin cuota aprox. en condiciones, precio de lanzamiento ni cuota referencial
- Comisiones: quita el valor estimado de las 10 primeras cuotas
- Playbook: speech, objeción, tabla de precios y herramientas sin valor de cuota

Co-Authored-By: Claude Opus 5.5 <noreply@anthropic.com>
Claude-Session: https://claude.ai/code/session_0111i7vn9WWo4QxCQbucWbrF
</commit_message>
<xml_diff>
--- a/playbook/salida/Playbook_Comercial_Cremacion_Vangrupo.pptx
+++ b/playbook/salida/Playbook_Comercial_Cremacion_Vangrupo.pptx
@@ -5522,7 +5522,7 @@
                 </a:solidFill>
                 <a:latin typeface="Montserrat"/>
               </a:rPr>
-              <a:t>Hasta 120 cuotas mensuales (≈ US$ 8,50/mes)</a:t>
+              <a:t>Pago en hasta 120 meses, con intereses</a:t>
             </a:r>
           </a:p>
         </p:txBody>
@@ -6585,7 +6585,7 @@
                 </a:solidFill>
                 <a:latin typeface="Playfair Display"/>
               </a:rPr>
-              <a:t>«Usted ya protegió a su familia con su plan. Por menos de lo que cuesta un refresco a la semana, alrededor de ocho dólares al mes, puede sumar la cremación completa, con urna, trámites y un año de columbario incluido. Así nadie tendrá que decidir ni pagar de golpe en un momento difícil.»</a:t>
+              <a:t>«Usted ya protegió a su familia con su plan. Pagando en hasta 120 meses, puede sumar la cremación completa, con urna, trámites y un año de columbario incluido. Así nadie tendrá que decidir ni pagar de golpe en un momento difícil.»</a:t>
             </a:r>
           </a:p>
         </p:txBody>
@@ -21820,7 +21820,7 @@
                 </a:solidFill>
                 <a:latin typeface="Montserrat"/>
               </a:rPr>
-              <a:t>En la urgencia los costos son mayores y se pagan de golpe. Hoy fija el precio y lo paga en cuotas: la Solución Modular cuesta alrededor de US$ 8,50 al mes.</a:t>
+              <a:t>En la urgencia los costos son mayores y se pagan de golpe. Hoy fija el precio y lo paga en cuotas: la Solución Modular se paga en hasta 120 meses.</a:t>
             </a:r>
           </a:p>
         </p:txBody>
@@ -21934,7 +21934,7 @@
                 </a:solidFill>
                 <a:latin typeface="Montserrat"/>
               </a:rPr>
-              <a:t>«¿Qué cuota mensual le resultaría cómoda?»</a:t>
+              <a:t>«¿Le resulta más cómodo pagarlo en cuotas mensuales?»</a:t>
             </a:r>
           </a:p>
         </p:txBody>
@@ -25293,7 +25293,7 @@
                           </a:solidFill>
                           <a:latin typeface="Montserrat"/>
                         </a:rPr>
-                        <a:t>Hasta 120 cuotas (≈ US$ 8,50/mes)</a:t>
+                        <a:t>Hasta 120 meses, con intereses</a:t>
                       </a:r>
                     </a:p>
                   </a:txBody>
@@ -29971,7 +29971,7 @@
                 </a:solidFill>
                 <a:latin typeface="Montserrat"/>
               </a:rPr>
-              <a:t>Simulación de cuotas</a:t>
+              <a:t>Plazo de pago</a:t>
             </a:r>
           </a:p>
           <a:p>
@@ -29990,7 +29990,7 @@
                 </a:solidFill>
                 <a:latin typeface="Montserrat"/>
               </a:rPr>
-              <a:t>Calcule la cuota con el cliente: transparencia genera confianza.</a:t>
+              <a:t>Explique que se paga en hasta 120 meses con intereses; no prometa un valor de cuota.</a:t>
             </a:r>
           </a:p>
         </p:txBody>

</xml_diff>

<commit_message>
Playbook: actualización completa según la ficha técnica
- Precio de lanzamiento (−20%) en cada producto, tabla y regla de descuentos
- Individual y Familiar: 30 años desde la primera inhumación, renovables
- Mantenimiento Familiar US$ 24
- Mascotas: US$ 550 con cremación y urna; placa memorial incluida en ambas opciones
- Columbario de la Solución Modular en Hogar de las Memorias
- Versión 1.1

Co-Authored-By: Claude Opus 5.5 <noreply@anthropic.com>
Claude-Session: https://claude.ai/code/session_0111i7vn9WWo4QxCQbucWbrF
</commit_message>
<xml_diff>
--- a/playbook/salida/Playbook_Comercial_Cremacion_Vangrupo.pptx
+++ b/playbook/salida/Playbook_Comercial_Cremacion_Vangrupo.pptx
@@ -3748,7 +3748,7 @@
                 </a:solidFill>
                 <a:latin typeface="Montserrat"/>
               </a:rPr>
-              <a:t>Versión 1.0 · Octubre 2026 · Uso interno del equipo comercial</a:t>
+              <a:t>Versión 1.1 · Octubre 2026 · Uso interno del equipo comercial</a:t>
             </a:r>
           </a:p>
         </p:txBody>
@@ -5522,7 +5522,7 @@
                 </a:solidFill>
                 <a:latin typeface="Montserrat"/>
               </a:rPr>
-              <a:t>Pago en hasta 120 meses, con intereses</a:t>
+              <a:t>Lanzamiento (−20%): US$ 800 · Pago en hasta 120 meses, con intereses</a:t>
             </a:r>
           </a:p>
         </p:txBody>
@@ -5866,7 +5866,7 @@
                 </a:solidFill>
                 <a:latin typeface="Montserrat"/>
               </a:rPr>
-              <a:t>Alquiler temporal de columbario por 1 año (nivel 1, Hogar de las Memorias)</a:t>
+              <a:t>Alquiler temporal de columbario por 1 año en Hogar de las Memorias</a:t>
             </a:r>
           </a:p>
         </p:txBody>
@@ -7746,7 +7746,7 @@
                 </a:solidFill>
                 <a:latin typeface="Montserrat"/>
               </a:rPr>
-              <a:t>Pago único o financiado · Mantenimiento US$ 15/año</a:t>
+              <a:t>Lanzamiento (−20%): US$ 480 · Pago único o financiado · Mantenimiento US$ 15/año</a:t>
             </a:r>
           </a:p>
         </p:txBody>
@@ -7797,7 +7797,7 @@
                 </a:solidFill>
                 <a:latin typeface="Montserrat"/>
               </a:rPr>
-              <a:t>Inhumación de la urna en un contenedor enterrado con tapa de granito grabada, en un jardín de plantas de sombra: un lugar permanente para visitar.</a:t>
+              <a:t>Inhumación de la urna en un contenedor enterrado con tapa de granito grabada, en un jardín de plantas de sombra: un lugar para visitar por 30 años desde la primera inhumación, renovable.</a:t>
             </a:r>
           </a:p>
           <a:p>
@@ -7825,7 +7825,7 @@
                 </a:solidFill>
                 <a:latin typeface="Montserrat"/>
               </a:rPr>
-              <a:t>Familias que quieren un lugar permanente para visitar, con una inversión moderada.</a:t>
+              <a:t>Familias que quieren un lugar propio para visitar, con una inversión moderada.</a:t>
             </a:r>
           </a:p>
         </p:txBody>
@@ -8299,7 +8299,7 @@
                 </a:solidFill>
                 <a:latin typeface="Montserrat"/>
               </a:rPr>
-              <a:t>Cuota de mantenimiento anual: US$ 15.</a:t>
+              <a:t>Cuota de mantenimiento anual: US$ 15. Permanencia: 30 años desde la primera inhumación, renovable.</a:t>
             </a:r>
           </a:p>
           <a:p>
@@ -9942,7 +9942,7 @@
                 </a:solidFill>
                 <a:latin typeface="Montserrat"/>
               </a:rPr>
-              <a:t>Pago único o financiado · Mantenimiento US$ 25/año</a:t>
+              <a:t>Lanzamiento (−20%): US$ 1.600 · Pago único o financiado · Mantenimiento US$ 24/año</a:t>
             </a:r>
           </a:p>
         </p:txBody>
@@ -9993,7 +9993,7 @@
                 </a:solidFill>
                 <a:latin typeface="Montserrat"/>
               </a:rPr>
-              <a:t>Parcela familiar en el Jardín 1 con cuatro contenedores agrupados, cada uno con tapa de granito grabada. Sin plazo de permanencia.</a:t>
+              <a:t>Parcela familiar en el Jardín 1 con cuatro contenedores agrupados, cada uno con tapa de granito grabada. Permanencia de 30 años desde la primera inhumación, renovable.</a:t>
             </a:r>
           </a:p>
           <a:p>
@@ -10021,7 +10021,7 @@
                 </a:solidFill>
                 <a:latin typeface="Montserrat"/>
               </a:rPr>
-              <a:t>Familias que buscan un espacio propio y permanente para varias generaciones.</a:t>
+              <a:t>Familias que buscan un espacio propio para varias generaciones.</a:t>
             </a:r>
           </a:p>
         </p:txBody>
@@ -10286,7 +10286,7 @@
                 </a:solidFill>
                 <a:latin typeface="Montserrat"/>
               </a:rPr>
-              <a:t>Lugar permanente de homenaje familiar, sin plazo</a:t>
+              <a:t>Lugar de homenaje familiar por 30 años, renovable por igual período</a:t>
             </a:r>
           </a:p>
         </p:txBody>
@@ -10495,7 +10495,7 @@
                 </a:solidFill>
                 <a:latin typeface="Montserrat"/>
               </a:rPr>
-              <a:t>Permanencia: sin plazo.</a:t>
+              <a:t>Permanencia: 30 años desde la primera inhumación, renovable por igual período.</a:t>
             </a:r>
           </a:p>
           <a:p>
@@ -10523,7 +10523,7 @@
                 </a:solidFill>
                 <a:latin typeface="Montserrat"/>
               </a:rPr>
-              <a:t>Cuota de mantenimiento anual: US$ 25 por parcela.</a:t>
+              <a:t>Cuota de mantenimiento anual: US$ 24 por parcela.</a:t>
             </a:r>
           </a:p>
         </p:txBody>
@@ -10977,7 +10977,7 @@
                 </a:solidFill>
                 <a:latin typeface="Playfair Display"/>
               </a:rPr>
-              <a:t>«Así como una familia comparte una casa, también puede compartir un lugar de memoria. La parcela familiar reúne hasta cuatro seres queridos en un mismo espacio, para siempre, y cuesta US$ 500 por espacio, menos que comprarlos por separado.»</a:t>
+              <a:t>«Así como una familia comparte una casa, también puede compartir un lugar de memoria. La parcela familiar reúne hasta cuatro seres queridos en un mismo espacio, por 30 años renovables, y cuesta US$ 500 por espacio (US$ 400 con el precio de lanzamiento), menos que comprarlos por separado.»</a:t>
             </a:r>
           </a:p>
         </p:txBody>
@@ -12138,7 +12138,7 @@
                 </a:solidFill>
                 <a:latin typeface="Montserrat"/>
               </a:rPr>
-              <a:t>Pago único o financiado · Placa memorial incluida</a:t>
+              <a:t>Lanzamiento (−20%): US$ 600 · Pago único o financiado · Placa memorial incluida</a:t>
             </a:r>
           </a:p>
         </p:txBody>
@@ -13280,34 +13280,6 @@
                 </a:solidFill>
                 <a:latin typeface="Montserrat"/>
               </a:rPr>
-              <a:t>Jardín de Mascotas: confirmar si la urna biodegradable está incluida en el precio.</a:t>
-            </a:r>
-          </a:p>
-          <a:p>
-            <a:pPr algn="l">
-              <a:lnSpc>
-                <a:spcPct val="115000"/>
-              </a:lnSpc>
-              <a:spcAft>
-                <a:spcPts val="400"/>
-              </a:spcAft>
-            </a:pPr>
-            <a:r>
-              <a:rPr sz="900" b="1" i="0">
-                <a:solidFill>
-                  <a:srgbClr val="C9A86A"/>
-                </a:solidFill>
-                <a:latin typeface="Montserrat"/>
-              </a:rPr>
-              <a:t>■  </a:t>
-            </a:r>
-            <a:r>
-              <a:rPr sz="1200" b="0" i="0">
-                <a:solidFill>
-                  <a:srgbClr val="2E2A36"/>
-                </a:solidFill>
-                <a:latin typeface="Montserrat"/>
-              </a:rPr>
               <a:t>Placas de madera: confirmar el tratamiento de la madera para contacto con el suelo.</a:t>
             </a:r>
           </a:p>
@@ -16323,7 +16295,7 @@
                 </a:solidFill>
                 <a:latin typeface="Montserrat"/>
               </a:rPr>
-              <a:t>US$ 400 solo espacio · US$ 550 con placa memorial incluida</a:t>
+              <a:t>Lanzamiento (−20%): US$ 320 / US$ 440 · US$ 400 solo espacio · US$ 550 con cremación</a:t>
             </a:r>
           </a:p>
         </p:txBody>
@@ -16374,7 +16346,7 @@
                 </a:solidFill>
                 <a:latin typeface="Montserrat"/>
               </a:rPr>
-              <a:t>Inhumación ecológica de las cenizas de la mascota: la urna biodegradable se entierra en el jardín y se identifica con una placa de madera.</a:t>
+              <a:t>Inhumación ecológica de las cenizas de la mascota: la urna biodegradable se entierra en el jardín y se identifica con una placa de madera. La opción de US$ 550 incluye también la cremación de la mascota.</a:t>
             </a:r>
           </a:p>
           <a:p>
@@ -16583,7 +16555,7 @@
                 </a:solidFill>
                 <a:latin typeface="Montserrat"/>
               </a:rPr>
-              <a:t>Inhumación ecológica en el jardín de mascotas</a:t>
+              <a:t>Inhumación ecológica en el jardín de mascotas; cremación y urna biodegradable en la opción de US$ 550</a:t>
             </a:r>
           </a:p>
           <a:p>
@@ -16667,7 +16639,7 @@
                 </a:solidFill>
                 <a:latin typeface="Montserrat"/>
               </a:rPr>
-              <a:t>Placa memorial en el monumento al término del plazo (opción US$ 550)</a:t>
+              <a:t>Placa memorial en el monumento al término del plazo (incluida)</a:t>
             </a:r>
           </a:p>
         </p:txBody>
@@ -16904,7 +16876,7 @@
                 </a:solidFill>
                 <a:latin typeface="Montserrat"/>
               </a:rPr>
-              <a:t>Placa memorial en el monumento: incluida solo en la opción de US$ 550.</a:t>
+              <a:t>Placa memorial incluida. Urna biodegradable incluida solo con cremación (US$ 550); con solo espacio (US$ 400) se compra aparte.</a:t>
             </a:r>
           </a:p>
           <a:p>
@@ -17595,7 +17567,7 @@
                 </a:solidFill>
                 <a:latin typeface="Montserrat"/>
               </a:rPr>
-              <a:t>¿Les gustaría que su nombre quede para siempre en el monumento memorial?</a:t>
+              <a:t>¿Ya se realizó la cremación o necesitan también ese servicio?</a:t>
             </a:r>
           </a:p>
           <a:p>
@@ -17795,7 +17767,7 @@
                 </a:solidFill>
                 <a:latin typeface="Montserrat"/>
               </a:rPr>
-              <a:t>«¿Prefieren la opción con placa memorial incluida, para que su nombre quede siempre en el jardín?»</a:t>
+              <a:t>«¿Prefieren la opción con cremación incluida, para resolver todo en un solo paso?»</a:t>
             </a:r>
           </a:p>
         </p:txBody>
@@ -23948,7 +23920,7 @@
                 </a:solidFill>
                 <a:latin typeface="Montserrat"/>
               </a:rPr>
-              <a:t>La cuota (US$ 15 o US$ 25 al año) mantiene el jardín siempre cuidado: poda, riego y limpieza. Es lo que garantiza que el lugar luzca digno en cada visita.</a:t>
+              <a:t>La cuota (US$ 15 o US$ 24 al año) mantiene el jardín siempre cuidado: poda, riego y limpieza. Es lo que garantiza que el lugar luzca digno en cada visita.</a:t>
             </a:r>
           </a:p>
         </p:txBody>
@@ -25271,7 +25243,7 @@
                           </a:solidFill>
                           <a:latin typeface="Montserrat"/>
                         </a:rPr>
-                        <a:t>US$ 1.000</a:t>
+                        <a:t>US$ 1.000 · lanz. US$ 800</a:t>
                       </a:r>
                     </a:p>
                   </a:txBody>
@@ -25383,7 +25355,7 @@
                           </a:solidFill>
                           <a:latin typeface="Montserrat"/>
                         </a:rPr>
-                        <a:t>US$ 600</a:t>
+                        <a:t>US$ 600 · lanz. US$ 480</a:t>
                       </a:r>
                     </a:p>
                   </a:txBody>
@@ -25449,7 +25421,7 @@
                           </a:solidFill>
                           <a:latin typeface="Montserrat"/>
                         </a:rPr>
-                        <a:t>Sin plazo</a:t>
+                        <a:t>30 años, renovable</a:t>
                       </a:r>
                     </a:p>
                   </a:txBody>
@@ -25495,7 +25467,7 @@
                           </a:solidFill>
                           <a:latin typeface="Montserrat"/>
                         </a:rPr>
-                        <a:t>US$ 2.000</a:t>
+                        <a:t>US$ 2.000 · lanz. US$ 1.600</a:t>
                       </a:r>
                     </a:p>
                   </a:txBody>
@@ -25539,7 +25511,7 @@
                           </a:solidFill>
                           <a:latin typeface="Montserrat"/>
                         </a:rPr>
-                        <a:t>US$ 25/año</a:t>
+                        <a:t>US$ 24/año</a:t>
                       </a:r>
                     </a:p>
                   </a:txBody>
@@ -25561,7 +25533,7 @@
                           </a:solidFill>
                           <a:latin typeface="Montserrat"/>
                         </a:rPr>
-                        <a:t>Hasta 4 espacios, sin plazo</a:t>
+                        <a:t>Hasta 4 espacios · 30 años, renovable</a:t>
                       </a:r>
                     </a:p>
                   </a:txBody>
@@ -25607,7 +25579,7 @@
                           </a:solidFill>
                           <a:latin typeface="Montserrat"/>
                         </a:rPr>
-                        <a:t>US$ 750</a:t>
+                        <a:t>US$ 750 · lanz. US$ 600</a:t>
                       </a:r>
                     </a:p>
                   </a:txBody>
@@ -25719,7 +25691,7 @@
                           </a:solidFill>
                           <a:latin typeface="Montserrat"/>
                         </a:rPr>
-                        <a:t>US$ 400 / 550</a:t>
+                        <a:t>US$ 400 / 550 · lanz. US$ 320 / 440</a:t>
                       </a:r>
                     </a:p>
                   </a:txBody>
@@ -25785,7 +25757,7 @@
                           </a:solidFill>
                           <a:latin typeface="Montserrat"/>
                         </a:rPr>
-                        <a:t>3 años · placa incluida en la opción de US$ 550</a:t>
+                        <a:t>3 años · placa incluida · cremación y urna en la opción de US$ 550</a:t>
                       </a:r>
                     </a:p>
                   </a:txBody>
@@ -26438,7 +26410,7 @@
                           </a:solidFill>
                           <a:latin typeface="Montserrat"/>
                         </a:rPr>
-                        <a:t>Prenecesidad: hasta 20% según la campaña del mes. Emergencia: máximo 5%. Siempre con autorización del supervisor.</a:t>
+                        <a:t>Precio de lanzamiento: 20% de descuento especial en todos los productos (ver Ficha Técnica). Cualquier otro descuento, solo con autorización del supervisor (emergencia: máximo 5%).</a:t>
                       </a:r>
                     </a:p>
                   </a:txBody>
@@ -26484,7 +26456,7 @@
                           </a:solidFill>
                           <a:latin typeface="Montserrat"/>
                         </a:rPr>
-                        <a:t>Individual US$ 15/año y Familiar US$ 25/año. No es opcional: se explica antes de firmar.</a:t>
+                        <a:t>Individual US$ 15/año y Familiar US$ 24/año. No es opcional: se explica antes de firmar.</a:t>
                       </a:r>
                     </a:p>
                   </a:txBody>
@@ -26508,7 +26480,7 @@
                           </a:solidFill>
                           <a:latin typeface="Montserrat"/>
                         </a:rPr>
-                        <a:t>Plazo de 3 años</a:t>
+                        <a:t>Plazos</a:t>
                       </a:r>
                     </a:p>
                   </a:txBody>
@@ -26530,7 +26502,7 @@
                           </a:solidFill>
                           <a:latin typeface="Montserrat"/>
                         </a:rPr>
-                        <a:t>Ecológico y Mascotas: se explica con total transparencia en la primera conversación.</a:t>
+                        <a:t>Individual y Familiar: 30 años desde la primera inhumación, renovables. Ecológico y Mascotas: 3 años. Se explica con total transparencia en la primera conversación.</a:t>
                       </a:r>
                     </a:p>
                   </a:txBody>
@@ -26576,7 +26548,7 @@
                           </a:solidFill>
                           <a:latin typeface="Montserrat"/>
                         </a:rPr>
-                        <a:t>Incluida en el Jardín Ecológico (US$ 750) y en la opción de Mascotas de US$ 550.</a:t>
+                        <a:t>Incluida en el Jardín Ecológico y en el Jardín de Mascotas.</a:t>
                       </a:r>
                     </a:p>
                   </a:txBody>
@@ -27455,7 +27427,7 @@
                 </a:solidFill>
                 <a:latin typeface="Montserrat"/>
               </a:rPr>
-              <a:t>No generan comisión: cuotas de mantenimiento anual (US$ 15 / US$ 25).</a:t>
+              <a:t>No generan comisión: cuotas de mantenimiento anual (US$ 15 / US$ 24).</a:t>
             </a:r>
           </a:p>
           <a:p>
@@ -28622,7 +28594,7 @@
                           </a:solidFill>
                           <a:latin typeface="Montserrat"/>
                         </a:rPr>
-                        <a:t>Mascotas · con placa</a:t>
+                        <a:t>Mascotas · jardín + cremación</a:t>
                       </a:r>
                     </a:p>
                   </a:txBody>
@@ -29990,7 +29962,7 @@
                 </a:solidFill>
                 <a:latin typeface="Montserrat"/>
               </a:rPr>
-              <a:t>Explique que se paga en hasta 120 meses con intereses; no prometa un valor de cuota.</a:t>
+              <a:t>Comunique que se paga en hasta 120 meses con intereses; no prometa un valor de cuota.</a:t>
             </a:r>
           </a:p>
         </p:txBody>
@@ -30304,7 +30276,7 @@
                 </a:solidFill>
                 <a:latin typeface="Montserrat"/>
               </a:rPr>
-              <a:t>Expliqué la cuota de mantenimiento o el plazo de 3 años, según el caso.</a:t>
+              <a:t>Expliqué la cuota de mantenimiento y el plazo (30 años renovables o 3 años), según el caso.</a:t>
             </a:r>
           </a:p>
           <a:p>
@@ -31282,7 +31254,7 @@
                 </a:solidFill>
                 <a:latin typeface="Montserrat"/>
               </a:rPr>
-              <a:t>Desde US$ 400 y con financiamiento: un destino final al alcance de más familias.</a:t>
+              <a:t>Desde US$ 320 en lanzamiento y con financiamiento: un destino final al alcance de más familias.</a:t>
             </a:r>
           </a:p>
         </p:txBody>
@@ -32024,8 +31996,8 @@
         </p:blipFill>
         <p:spPr>
           <a:xfrm>
-            <a:off x="635698" y="1508760"/>
-            <a:ext cx="10920298" cy="4754880"/>
+            <a:off x="836994" y="1508760"/>
+            <a:ext cx="10517706" cy="4754880"/>
           </a:xfrm>
           <a:prstGeom prst="rect">
             <a:avLst/>

</xml_diff>

<commit_message>
Playbook: ajustar textos del portafolio existente de columbarios
Etiquetas más cortas y redacción de qué es, incluye y reglas alineada
con las nuevas páginas del Canva. Salidas regeneradas.

Co-Authored-By: Claude Opus 5.5 <noreply@anthropic.com>
Claude-Session: https://claude.ai/code/session_0111i7vn9WWo4QxCQbucWbrF
</commit_message>
<xml_diff>
--- a/playbook/salida/Playbook_Comercial_Cremacion_Vangrupo.pptx
+++ b/playbook/salida/Playbook_Comercial_Cremacion_Vangrupo.pptx
@@ -19576,7 +19576,7 @@
                 </a:solidFill>
                 <a:latin typeface="Montserrat"/>
               </a:rPr>
-              <a:t>HOGAR DE LAS MEMORIAS · FUNERAL + CREMACIÓN + COLUMBARIO</a:t>
+              <a:t>HOGAR DE LAS MEMORIAS · SERVICIO COMPLETO</a:t>
             </a:r>
           </a:p>
         </p:txBody>
@@ -19795,7 +19795,7 @@
                 </a:solidFill>
                 <a:latin typeface="Montserrat"/>
               </a:rPr>
-              <a:t>La solución más completa: servicio funerario, dos cremaciones y un columbario permanente de cristal o mármol para hasta dos urnas, en El Hogar de las Memorias.</a:t>
+              <a:t>Integra en un solo contrato el servicio funerario, dos cremaciones y un columbario permanente de cristal o mármol para hasta dos urnas, en El Hogar de las Memorias.</a:t>
             </a:r>
           </a:p>
           <a:p>
@@ -20004,7 +20004,7 @@
                 </a:solidFill>
                 <a:latin typeface="Montserrat"/>
               </a:rPr>
-              <a:t>Columbario estándar permanente de cristal o mármol, para hasta 2 urnas</a:t>
+              <a:t>Incluye columbario estándar permanente de cristal o mármol, para hasta 2 urnas</a:t>
             </a:r>
           </a:p>
           <a:p>
@@ -20032,7 +20032,7 @@
                 </a:solidFill>
                 <a:latin typeface="Montserrat"/>
               </a:rPr>
-              <a:t>2 cremaciones con certificado y 2 urnas cinerarias básicas</a:t>
+              <a:t>Traslados, preparación y resguardo hasta 5 días; Programa Vive de acompañamiento en el duelo</a:t>
             </a:r>
           </a:p>
           <a:p>
@@ -20060,7 +20060,7 @@
                 </a:solidFill>
                 <a:latin typeface="Montserrat"/>
               </a:rPr>
-              <a:t>Sala de velación 24 h, ataúd ceremonial y carroza tradicional</a:t>
+              <a:t>Urnas cinerarias básicas (2) y 2 cremaciones con certificado</a:t>
             </a:r>
           </a:p>
           <a:p>
@@ -20088,7 +20088,7 @@
                 </a:solidFill>
                 <a:latin typeface="Montserrat"/>
               </a:rPr>
-              <a:t>Traslados, preparación y resguardo hasta 5 días, y Programa Vive de acompañamiento en el duelo</a:t>
+              <a:t>Capilla de velación 24 h, ataúd ceremonial y carroza tradicional</a:t>
             </a:r>
           </a:p>
         </p:txBody>
@@ -20297,7 +20297,7 @@
                 </a:solidFill>
                 <a:latin typeface="Montserrat"/>
               </a:rPr>
-              <a:t>Ubicación definida: US$ 3.400 – 3.900. Ubicación a futuro: US$ 2.700 – 3.200 (según fila y nivel).</a:t>
+              <a:t>Con ubicación definida: US$ 3.400 – 3.900; a futuro: US$ 2.700 – 3.200 (según fila y nivel).</a:t>
             </a:r>
           </a:p>
           <a:p>
@@ -20325,7 +20325,7 @@
                 </a:solidFill>
                 <a:latin typeface="Montserrat"/>
               </a:rPr>
-              <a:t>Velación en La Auxiliadora (Capilla Maquilishuat o Básica) o en Capillas Memoriales (Las Camelias o Básica).</a:t>
+              <a:t>Elija velación en La Auxiliadora (Maquilishuat o Básica) o en Capillas Memoriales (Las Camelias o Básica).</a:t>
             </a:r>
           </a:p>
         </p:txBody>
@@ -21991,7 +21991,7 @@
                 </a:solidFill>
                 <a:latin typeface="Montserrat"/>
               </a:rPr>
-              <a:t>Columbario permanente de mármol o cristal en El Hogar de las Memorias: un espacio elegante y sereno, de diseño atemporal, para las urnas de la familia.</a:t>
+              <a:t>Ideal para las cenizas de la familia: columbario permanente de mármol o cristal en El Hogar de las Memorias, elegante, sereno y de diseño atemporal.</a:t>
             </a:r>
           </a:p>
           <a:p>
@@ -22200,7 +22200,7 @@
                 </a:solidFill>
                 <a:latin typeface="Montserrat"/>
               </a:rPr>
-              <a:t>Espacio permanente en columbario de mármol o cristal</a:t>
+              <a:t>Incluye espacio permanente en columbario de mármol o cristal</a:t>
             </a:r>
           </a:p>
           <a:p>
@@ -22228,7 +22228,7 @@
                 </a:solidFill>
                 <a:latin typeface="Montserrat"/>
               </a:rPr>
-              <a:t>Capacidad estándar: hasta 2 urnas</a:t>
+              <a:t>Tamaño estándar: hasta 2 urnas</a:t>
             </a:r>
           </a:p>
           <a:p>
@@ -22437,7 +22437,7 @@
                 </a:solidFill>
                 <a:latin typeface="Montserrat"/>
               </a:rPr>
-              <a:t>Solo columbario: la cremación se contrata aparte (por ejemplo, con la Solución Modular).</a:t>
+              <a:t>Cremación no incluida: se contrata aparte (por ejemplo, con la Solución Modular).</a:t>
             </a:r>
           </a:p>
           <a:p>
@@ -22465,7 +22465,7 @@
                 </a:solidFill>
                 <a:latin typeface="Montserrat"/>
               </a:rPr>
-              <a:t>Ubicación definida: US$ 2.600. Ubicación a futuro: US$ 1.200 – 1.900 (según fila y nivel).</a:t>
+              <a:t>Con ubicación definida: US$ 2.600; a futuro: US$ 1.200 – 1.900 (según fila y nivel).</a:t>
             </a:r>
           </a:p>
         </p:txBody>
@@ -24360,7 +24360,7 @@
                 </a:solidFill>
                 <a:latin typeface="Montserrat"/>
               </a:rPr>
-              <a:t>Finados y noviembre (−15%): US$ 2.635 / US$ 4.250 · Pago único o hasta 120 meses, con intereses</a:t>
+              <a:t>Finados y noviembre (−15%): US$ 2.635 / 4.250 · Único o hasta 120 meses, con intereses</a:t>
             </a:r>
           </a:p>
         </p:txBody>
@@ -24411,7 +24411,7 @@
                 </a:solidFill>
                 <a:latin typeface="Montserrat"/>
               </a:rPr>
-              <a:t>Columbario de ónix natural, una piedra de tonos cálidos y apariencia luminosa, para un homenaje exclusivo y perdurable.</a:t>
+              <a:t>Inspirado en la belleza del ónix natural, de tonos cálidos y apariencia luminosa: un columbario exclusivo para un homenaje perdurable.</a:t>
             </a:r>
           </a:p>
           <a:p>
@@ -24620,7 +24620,7 @@
                 </a:solidFill>
                 <a:latin typeface="Montserrat"/>
               </a:rPr>
-              <a:t>Espacio permanente en columbario de ónix natural</a:t>
+              <a:t>Incluye espacio permanente en columbario de ónix natural</a:t>
             </a:r>
           </a:p>
           <a:p>
@@ -24648,7 +24648,7 @@
                 </a:solidFill>
                 <a:latin typeface="Montserrat"/>
               </a:rPr>
-              <a:t>Estándar: hasta 2 urnas, con ubicación definida (US$ 3.100)</a:t>
+              <a:t>Tamaño estándar: hasta 2 urnas, con ubicación definida (US$ 3.100)</a:t>
             </a:r>
           </a:p>
           <a:p>
@@ -24676,7 +24676,7 @@
                 </a:solidFill>
                 <a:latin typeface="Montserrat"/>
               </a:rPr>
-              <a:t>Familiar: hasta 4 urnas, con ubicación a futuro (US$ 5.000)</a:t>
+              <a:t>Una opción familiar: hasta 4 urnas, con ubicación a futuro (US$ 5.000)</a:t>
             </a:r>
           </a:p>
         </p:txBody>
@@ -24857,7 +24857,7 @@
                 </a:solidFill>
                 <a:latin typeface="Montserrat"/>
               </a:rPr>
-              <a:t>Solo columbario: la cremación se contrata aparte.</a:t>
+              <a:t>Cremación no incluida: se contrata aparte.</a:t>
             </a:r>
           </a:p>
           <a:p>
@@ -24885,7 +24885,7 @@
                 </a:solidFill>
                 <a:latin typeface="Montserrat"/>
               </a:rPr>
-              <a:t>Estándar (2 urnas) con ubicación definida; Familiar (4 urnas) con ubicación a futuro.</a:t>
+              <a:t>Con la modalidad estándar la ubicación es definida; con la familiar, a futuro.</a:t>
             </a:r>
           </a:p>
         </p:txBody>
@@ -26304,7 +26304,7 @@
                 </a:solidFill>
                 <a:latin typeface="Montserrat"/>
               </a:rPr>
-              <a:t>HOGAR DE LAS MEMORIAS · COLUMBARIO FAMILIAR EXCLUSIVO</a:t>
+              <a:t>HOGAR DE LAS MEMORIAS · COLUMBARIO FAMILIAR</a:t>
             </a:r>
           </a:p>
         </p:txBody>
@@ -26523,7 +26523,7 @@
                 </a:solidFill>
                 <a:latin typeface="Montserrat"/>
               </a:rPr>
-              <a:t>Columbario familiar con tapa de ónix y obra de arte religiosa: una expresión única de fe, memoria y belleza para toda una familia.</a:t>
+              <a:t>Imagen religiosa sobre tapa de ónix: un columbario familiar que es una expresión única de fe, memoria y belleza.</a:t>
             </a:r>
           </a:p>
           <a:p>
@@ -26732,7 +26732,7 @@
                 </a:solidFill>
                 <a:latin typeface="Montserrat"/>
               </a:rPr>
-              <a:t>Columbario familiar permanente para hasta 4 urnas</a:t>
+              <a:t>Incluye columbario familiar permanente para hasta 4 urnas</a:t>
             </a:r>
           </a:p>
           <a:p>
@@ -26997,7 +26997,7 @@
                 </a:solidFill>
                 <a:latin typeface="Montserrat"/>
               </a:rPr>
-              <a:t>Solo columbario: la cremación se contrata aparte.</a:t>
+              <a:t>Cremación no incluida: se contrata aparte.</a:t>
             </a:r>
           </a:p>
         </p:txBody>
@@ -28416,7 +28416,7 @@
                 </a:solidFill>
                 <a:latin typeface="Montserrat"/>
               </a:rPr>
-              <a:t>MAUSOLEO VERTICAL BELLA VISTA · CREMACIÓN + COLUMBARIO</a:t>
+              <a:t>MAUSOLEO BELLA VISTA · CREMACIÓN + COLUMBARIO</a:t>
             </a:r>
           </a:p>
         </p:txBody>
@@ -28635,7 +28635,7 @@
                 </a:solidFill>
                 <a:latin typeface="Montserrat"/>
               </a:rPr>
-              <a:t>Columbario de cristal en el mausoleo vertical Bella Vista, dentro del cementerio, con el proceso completo de cremación incluido.</a:t>
+              <a:t>Incluye el proceso completo de cremación y un columbario de cristal en el mausoleo vertical Bella Vista, dentro del cementerio.</a:t>
             </a:r>
           </a:p>
           <a:p>
@@ -28844,7 +28844,7 @@
                 </a:solidFill>
                 <a:latin typeface="Montserrat"/>
               </a:rPr>
-              <a:t>Columbario de cristal permanente (30 × 30 × 30 cm)</a:t>
+              <a:t>Incluye columbario de cristal permanente (30 × 30 × 30 cm)</a:t>
             </a:r>
           </a:p>
           <a:p>
@@ -28872,7 +28872,7 @@
                 </a:solidFill>
                 <a:latin typeface="Montserrat"/>
               </a:rPr>
-              <a:t>Estándar: 2 cremaciones y 2 urnas · Familiar: 4 cremaciones y 4 urnas</a:t>
+              <a:t>Traslados, preparación y resguardo hasta 5 días</a:t>
             </a:r>
           </a:p>
           <a:p>
@@ -28900,7 +28900,7 @@
                 </a:solidFill>
                 <a:latin typeface="Montserrat"/>
               </a:rPr>
-              <a:t>Traslados, preparación y resguardo hasta 5 días</a:t>
+              <a:t>Urnas y cremaciones: 2 en la modalidad estándar, 4 en la familiar</a:t>
             </a:r>
           </a:p>
           <a:p>
@@ -29109,7 +29109,7 @@
                 </a:solidFill>
                 <a:latin typeface="Montserrat"/>
               </a:rPr>
-              <a:t>Estándar: ubicación definida US$ 1.800 · a futuro US$ 1.300.</a:t>
+              <a:t>Con modalidad estándar: definida US$ 1.800 · a futuro US$ 1.300.</a:t>
             </a:r>
           </a:p>
           <a:p>
@@ -29137,7 +29137,7 @@
                 </a:solidFill>
                 <a:latin typeface="Montserrat"/>
               </a:rPr>
-              <a:t>Familiar: ubicación definida US$ 2.900 · a futuro US$ 2.300.</a:t>
+              <a:t>Con modalidad familiar: definida US$ 2.900 · a futuro US$ 2.300.</a:t>
             </a:r>
           </a:p>
           <a:p>
@@ -29165,7 +29165,7 @@
                 </a:solidFill>
                 <a:latin typeface="Montserrat"/>
               </a:rPr>
-              <a:t>La cremación está incluida: no hace falta contratarla aparte.</a:t>
+              <a:t>En este producto la cremación está incluida: no hace falta contratarla aparte.</a:t>
             </a:r>
           </a:p>
         </p:txBody>

</xml_diff>

<commit_message>
Columbarios: ubicación definida o a futuro en todas las opciones
Ónix y Obra de Arte pasan a admitir ubicación definida o a futuro,
como los demás columbarios. Salidas regeneradas.

Co-Authored-By: Claude Opus 5.5 <noreply@anthropic.com>
Claude-Session: https://claude.ai/code/session_0111i7vn9WWo4QxCQbucWbrF
</commit_message>
<xml_diff>
--- a/playbook/salida/Playbook_Comercial_Cremacion_Vangrupo.pptx
+++ b/playbook/salida/Playbook_Comercial_Cremacion_Vangrupo.pptx
@@ -24648,7 +24648,7 @@
                 </a:solidFill>
                 <a:latin typeface="Montserrat"/>
               </a:rPr>
-              <a:t>Tamaño estándar: hasta 2 urnas, con ubicación definida (US$ 3.100)</a:t>
+              <a:t>Tamaño estándar: hasta 2 urnas (US$ 3.100)</a:t>
             </a:r>
           </a:p>
           <a:p>
@@ -24676,7 +24676,7 @@
                 </a:solidFill>
                 <a:latin typeface="Montserrat"/>
               </a:rPr>
-              <a:t>Una opción familiar: hasta 4 urnas, con ubicación a futuro (US$ 5.000)</a:t>
+              <a:t>Una opción familiar: hasta 4 urnas (US$ 5.000)</a:t>
             </a:r>
           </a:p>
         </p:txBody>
@@ -24885,7 +24885,7 @@
                 </a:solidFill>
                 <a:latin typeface="Montserrat"/>
               </a:rPr>
-              <a:t>Con la modalidad estándar la ubicación es definida; con la familiar, a futuro.</a:t>
+              <a:t>Con ubicación definida o a futuro en ambas modalidades (según fila y nivel).</a:t>
             </a:r>
           </a:p>
         </p:txBody>
@@ -26788,7 +26788,7 @@
                 </a:solidFill>
                 <a:latin typeface="Montserrat"/>
               </a:rPr>
-              <a:t>Ubicación definida</a:t>
+              <a:t>Ubicación definida o a futuro</a:t>
             </a:r>
           </a:p>
         </p:txBody>

</xml_diff>

<commit_message>
Columbarios: Ónix estándar definida / familiar a futuro; Obra de Arte solo definida
Revierte el cambio anterior: Obra de Arte es solo familiar con ubicación
definida; Ónix estándar es ubicación definida y familiar, a futuro.

Co-Authored-By: Claude Opus 5.5 <noreply@anthropic.com>
Claude-Session: https://claude.ai/code/session_0111i7vn9WWo4QxCQbucWbrF
</commit_message>
<xml_diff>
--- a/playbook/salida/Playbook_Comercial_Cremacion_Vangrupo.pptx
+++ b/playbook/salida/Playbook_Comercial_Cremacion_Vangrupo.pptx
@@ -24648,7 +24648,7 @@
                 </a:solidFill>
                 <a:latin typeface="Montserrat"/>
               </a:rPr>
-              <a:t>Tamaño estándar: hasta 2 urnas (US$ 3.100)</a:t>
+              <a:t>Tamaño estándar: hasta 2 urnas, con ubicación definida (US$ 3.100)</a:t>
             </a:r>
           </a:p>
           <a:p>
@@ -24676,7 +24676,7 @@
                 </a:solidFill>
                 <a:latin typeface="Montserrat"/>
               </a:rPr>
-              <a:t>Una opción familiar: hasta 4 urnas (US$ 5.000)</a:t>
+              <a:t>Una opción familiar: hasta 4 urnas, con ubicación a futuro (US$ 5.000)</a:t>
             </a:r>
           </a:p>
         </p:txBody>
@@ -24885,7 +24885,7 @@
                 </a:solidFill>
                 <a:latin typeface="Montserrat"/>
               </a:rPr>
-              <a:t>Con ubicación definida o a futuro en ambas modalidades (según fila y nivel).</a:t>
+              <a:t>Con la modalidad estándar la ubicación es definida; con la familiar, a futuro.</a:t>
             </a:r>
           </a:p>
         </p:txBody>
@@ -26788,7 +26788,7 @@
                 </a:solidFill>
                 <a:latin typeface="Montserrat"/>
               </a:rPr>
-              <a:t>Ubicación definida o a futuro</a:t>
+              <a:t>Ubicación definida</a:t>
             </a:r>
           </a:p>
         </p:txBody>

</xml_diff>

<commit_message>
Playbook: reemplaza comillas angulares por comillas dobles
Co-Authored-By: Claude Opus 5.5 <noreply@anthropic.com>
Claude-Session: https://claude.ai/code/session_0111i7vn9WWo4QxCQbucWbrF
</commit_message>
<xml_diff>
--- a/playbook/salida/Playbook_Comercial_Cremacion_Vangrupo.pptx
+++ b/playbook/salida/Playbook_Comercial_Cremacion_Vangrupo.pptx
@@ -3397,7 +3397,7 @@
                 </a:solidFill>
                 <a:latin typeface="Playfair Display"/>
               </a:rPr>
-              <a:t>«Acompañar, no vender: la familia primero, siempre.»</a:t>
+              <a:t>"Acompañar, no vender: la familia primero, siempre."</a:t>
             </a:r>
           </a:p>
         </p:txBody>
@@ -6597,7 +6597,7 @@
                 </a:solidFill>
                 <a:latin typeface="Playfair Display"/>
               </a:rPr>
-              <a:t>«Usted ya protegió a su familia con su plan. Pagando en hasta 120 meses, puede sumar la cremación completa, con urna, trámites y un año de columbario incluido. Así nadie tendrá que decidir ni pagar de golpe en un momento difícil.»</a:t>
+              <a:t>"Usted ya protegió a su familia con su plan. Pagando en hasta 120 meses, puede sumar la cremación completa, con urna, trámites y un año de columbario incluido. Así nadie tendrá que decidir ni pagar de golpe en un momento difícil."</a:t>
             </a:r>
           </a:p>
         </p:txBody>
@@ -7006,7 +7006,7 @@
                 </a:solidFill>
                 <a:latin typeface="Montserrat"/>
               </a:rPr>
-              <a:t>«¿Le parece si lo sumamos a su plan desde este mes, con la primera cuota de hoy?»</a:t>
+              <a:t>"¿Le parece si lo sumamos a su plan desde este mes, con la primera cuota de hoy?"</a:t>
             </a:r>
           </a:p>
         </p:txBody>
@@ -7178,7 +7178,7 @@
                 </a:solidFill>
                 <a:latin typeface="Montserrat"/>
               </a:rPr>
-              <a:t>«Mi plan ya es suficiente.» → «Su plan cubre el servicio funerario; la cremación y la urna se pagarían aparte y de una sola vez. Con el módulo queda todo cubierto en cuotas pequeñas.»</a:t>
+              <a:t>"Mi plan ya es suficiente." → "Su plan cubre el servicio funerario; la cremación y la urna se pagarían aparte y de una sola vez. Con el módulo queda todo cubierto en cuotas pequeñas."</a:t>
             </a:r>
           </a:p>
         </p:txBody>
@@ -8793,7 +8793,7 @@
                 </a:solidFill>
                 <a:latin typeface="Playfair Display"/>
               </a:rPr>
-              <a:t>«Después de la cremación, muchas familias se preguntan dónde dejar las cenizas. En nuestro Jardín 1, su ser querido descansa bajo una tapa de granito con su nombre, rodeado de plantas y con un banco para sentarse a recordar. Es un lugar para volver, con la dignidad que merece.»</a:t>
+              <a:t>"Después de la cremación, muchas familias se preguntan dónde dejar las cenizas. En nuestro Jardín 1, su ser querido descansa bajo una tapa de granito con su nombre, rodeado de plantas y con un banco para sentarse a recordar. Es un lugar para volver, con la dignidad que merece."</a:t>
             </a:r>
           </a:p>
         </p:txBody>
@@ -9202,7 +9202,7 @@
                 </a:solidFill>
                 <a:latin typeface="Montserrat"/>
               </a:rPr>
-              <a:t>«¿Le gustaría conocer el jardín esta semana para elegir el lugar con calma?»</a:t>
+              <a:t>"¿Le gustaría conocer el jardín esta semana para elegir el lugar con calma?"</a:t>
             </a:r>
           </a:p>
         </p:txBody>
@@ -9374,7 +9374,7 @@
                 </a:solidFill>
                 <a:latin typeface="Montserrat"/>
               </a:rPr>
-              <a:t>«Prefiero tener las cenizas en casa.» → «Es comprensible querer tenerlas cerca. En el jardín, toda la familia puede visitarlas, y las cenizas quedan protegidas si algún día hay mudanzas o cambios en el hogar.»</a:t>
+              <a:t>"Prefiero tener las cenizas en casa." → "Es comprensible querer tenerlas cerca. En el jardín, toda la familia puede visitarlas, y las cenizas quedan protegidas si algún día hay mudanzas o cambios en el hogar."</a:t>
             </a:r>
           </a:p>
         </p:txBody>
@@ -10989,7 +10989,7 @@
                 </a:solidFill>
                 <a:latin typeface="Playfair Display"/>
               </a:rPr>
-              <a:t>«Así como una familia comparte una casa, también puede compartir un lugar de memoria. La parcela familiar reúne hasta cuatro seres queridos en un mismo espacio, por 30 años renovables, y cuesta US$ 500 por espacio (US$ 400 con el precio de lanzamiento), menos que comprarlos por separado.»</a:t>
+              <a:t>"Así como una familia comparte una casa, también puede compartir un lugar de memoria. La parcela familiar reúne hasta cuatro seres queridos en un mismo espacio, por 30 años renovables, y cuesta US$ 500 por espacio (US$ 400 con el precio de lanzamiento), menos que comprarlos por separado."</a:t>
             </a:r>
           </a:p>
         </p:txBody>
@@ -11398,7 +11398,7 @@
                 </a:solidFill>
                 <a:latin typeface="Montserrat"/>
               </a:rPr>
-              <a:t>«¿Reservamos hoy la parcela para su familia y la pagan en cuotas cómodas?»</a:t>
+              <a:t>"¿Reservamos hoy la parcela para su familia y la pagan en cuotas cómodas?"</a:t>
             </a:r>
           </a:p>
         </p:txBody>
@@ -11570,7 +11570,7 @@
                 </a:solidFill>
                 <a:latin typeface="Montserrat"/>
               </a:rPr>
-              <a:t>«Es mucho dinero.» → «Son US$ 500 por cada espacio, con financiamiento. Y es una decisión que se toma una sola vez para toda la familia.»</a:t>
+              <a:t>"Es mucho dinero." → "Son US$ 500 por cada espacio, con financiamiento. Y es una decisión que se toma una sola vez para toda la familia."</a:t>
             </a:r>
           </a:p>
         </p:txBody>
@@ -14840,7 +14840,7 @@
                 </a:solidFill>
                 <a:latin typeface="Playfair Display"/>
               </a:rPr>
-              <a:t>«Para quienes aman la naturaleza, el Jardín Ecológico es volver a la tierra. La urna se integra al suelo del bosque, junto al agua, y durante tres años la familia tiene un lugar señalado para visitar. Después, el nombre queda para siempre en el monumento memorial del jardín.»</a:t>
+              <a:t>"Para quienes aman la naturaleza, el Jardín Ecológico es volver a la tierra. La urna se integra al suelo del bosque, junto al agua, y durante tres años la familia tiene un lugar señalado para visitar. Después, el nombre queda para siempre en el monumento memorial del jardín."</a:t>
             </a:r>
           </a:p>
         </p:txBody>
@@ -15049,7 +15049,7 @@
                 </a:solidFill>
                 <a:latin typeface="Montserrat"/>
               </a:rPr>
-              <a:t>¿Qué significa para ustedes «volver a la tierra»?</a:t>
+              <a:t>¿Qué significa para ustedes "volver a la tierra"?</a:t>
             </a:r>
           </a:p>
           <a:p>
@@ -15249,7 +15249,7 @@
                 </a:solidFill>
                 <a:latin typeface="Montserrat"/>
               </a:rPr>
-              <a:t>«¿Le parece si visitamos el Bosque de las Orquídeas y elegimos juntos el lugar?»</a:t>
+              <a:t>"¿Le parece si visitamos el Bosque de las Orquídeas y elegimos juntos el lugar?"</a:t>
             </a:r>
           </a:p>
         </p:txBody>
@@ -15421,7 +15421,7 @@
                 </a:solidFill>
                 <a:latin typeface="Montserrat"/>
               </a:rPr>
-              <a:t>«¿Y después de 3 años?» → «La urna ya se habrá integrado a la tierra, como era el deseo. El nombre pasa a la placa memorial del monumento, que queda para siempre en el jardín.»</a:t>
+              <a:t>"¿Y después de 3 años?" → "La urna ya se habrá integrado a la tierra, como era el deseo. El nombre pasa a la placa memorial del monumento, que queda para siempre en el jardín."</a:t>
             </a:r>
           </a:p>
         </p:txBody>
@@ -17370,7 +17370,7 @@
                 </a:solidFill>
                 <a:latin typeface="Playfair Display"/>
               </a:rPr>
-              <a:t>«Su compañero fue parte de la familia, y merece una despedida a la altura. En nuestro Jardín de Mascotas descansa con su nombre, en un lugar verde donde ustedes pueden volver a recordarlo. Y con la placa memorial, su nombre queda para siempre en el monumento del jardín.»</a:t>
+              <a:t>"Su compañero fue parte de la familia, y merece una despedida a la altura. En nuestro Jardín de Mascotas descansa con su nombre, en un lugar verde donde ustedes pueden volver a recordarlo. Y con la placa memorial, su nombre queda para siempre en el monumento del jardín."</a:t>
             </a:r>
           </a:p>
         </p:txBody>
@@ -17779,7 +17779,7 @@
                 </a:solidFill>
                 <a:latin typeface="Montserrat"/>
               </a:rPr>
-              <a:t>«¿Prefieren la opción con cremación incluida, para resolver todo en un solo paso?»</a:t>
+              <a:t>"¿Prefieren la opción con cremación incluida, para resolver todo en un solo paso?"</a:t>
             </a:r>
           </a:p>
         </p:txBody>
@@ -17951,7 +17951,7 @@
                 </a:solidFill>
                 <a:latin typeface="Montserrat"/>
               </a:rPr>
-              <a:t>«Es solo una mascota.» → No discuta el vínculo de la familia. Si el cliente minimiza, respete y ofrezca la información por escrito para que decida con calma.</a:t>
+              <a:t>"Es solo una mascota." → No discuta el vínculo de la familia. Si el cliente minimiza, respete y ofrezca la información por escrito para que decida con calma.</a:t>
             </a:r>
           </a:p>
         </p:txBody>
@@ -19056,7 +19056,7 @@
                 </a:solidFill>
                 <a:latin typeface="Montserrat"/>
               </a:rPr>
-              <a:t>Si un cliente muestra interés, registre su contacto como «interesado Ceremonial».</a:t>
+              <a:t>Si un cliente muestra interés, registre su contacto como "interesado Ceremonial".</a:t>
             </a:r>
           </a:p>
         </p:txBody>
@@ -20779,7 +20779,7 @@
                 </a:solidFill>
                 <a:latin typeface="Playfair Display"/>
               </a:rPr>
-              <a:t>«Con el Supremo Plus su familia no tendrá que coordinar nada: el servicio funerario, la cremación y el lugar donde descansarán las cenizas quedan resueltos en un solo contrato, para dos personas y para siempre.»</a:t>
+              <a:t>"Con el Supremo Plus su familia no tendrá que coordinar nada: el servicio funerario, la cremación y el lugar donde descansarán las cenizas quedan resueltos en un solo contrato, para dos personas y para siempre."</a:t>
             </a:r>
           </a:p>
         </p:txBody>
@@ -21188,7 +21188,7 @@
                 </a:solidFill>
                 <a:latin typeface="Montserrat"/>
               </a:rPr>
-              <a:t>«¿Aprovechamos el precio de noviembre y elegimos hoy la ubicación?»</a:t>
+              <a:t>"¿Aprovechamos el precio de noviembre y elegimos hoy la ubicación?"</a:t>
             </a:r>
           </a:p>
         </p:txBody>
@@ -21360,7 +21360,7 @@
                 </a:solidFill>
                 <a:latin typeface="Montserrat"/>
               </a:rPr>
-              <a:t>«Es una inversión alta.» → «Incluye todo para dos personas: funeral, dos cremaciones y el columbario permanente. Y puede pagarse en hasta 120 meses.»</a:t>
+              <a:t>"Es una inversión alta." → "Incluye todo para dos personas: funeral, dos cremaciones y el columbario permanente. Y puede pagarse en hasta 120 meses."</a:t>
             </a:r>
           </a:p>
         </p:txBody>
@@ -22919,7 +22919,7 @@
                 </a:solidFill>
                 <a:latin typeface="Playfair Display"/>
               </a:rPr>
-              <a:t>«Las cenizas de su ser querido merecen un lugar propio y permanente. En El Hogar de las Memorias, el columbario de mármol o cristal guarda hasta dos urnas en un espacio sereno, donde la familia siempre podrá volver.»</a:t>
+              <a:t>"Las cenizas de su ser querido merecen un lugar propio y permanente. En El Hogar de las Memorias, el columbario de mármol o cristal guarda hasta dos urnas en un espacio sereno, donde la familia siempre podrá volver."</a:t>
             </a:r>
           </a:p>
         </p:txBody>
@@ -23328,7 +23328,7 @@
                 </a:solidFill>
                 <a:latin typeface="Montserrat"/>
               </a:rPr>
-              <a:t>«¿Visitamos El Hogar de las Memorias para que elija la fila y el nivel?»</a:t>
+              <a:t>"¿Visitamos El Hogar de las Memorias para que elija la fila y el nivel?"</a:t>
             </a:r>
           </a:p>
         </p:txBody>
@@ -23500,7 +23500,7 @@
                 </a:solidFill>
                 <a:latin typeface="Montserrat"/>
               </a:rPr>
-              <a:t>«Ya tengo las cenizas en casa.» → «Es natural tenerlas cerca. En el columbario quedan protegidas para siempre y toda la familia puede visitarlas.»</a:t>
+              <a:t>"Ya tengo las cenizas en casa." → "Es natural tenerlas cerca. En el columbario quedan protegidas para siempre y toda la familia puede visitarlas."</a:t>
             </a:r>
           </a:p>
         </p:txBody>
@@ -25339,7 +25339,7 @@
                 </a:solidFill>
                 <a:latin typeface="Playfair Display"/>
               </a:rPr>
-              <a:t>«El ónix es una piedra natural única: su luz y sus tonos cálidos hacen de cada espacio un lugar de paz. Es un homenaje distinto, a la altura de quien usted ama.»</a:t>
+              <a:t>"El ónix es una piedra natural única: su luz y sus tonos cálidos hacen de cada espacio un lugar de paz. Es un homenaje distinto, a la altura de quien usted ama."</a:t>
             </a:r>
           </a:p>
         </p:txBody>
@@ -25720,7 +25720,7 @@
                 </a:solidFill>
                 <a:latin typeface="Montserrat"/>
               </a:rPr>
-              <a:t>«¿Le muestro el columbario de ónix para que vea la piedra en persona?»</a:t>
+              <a:t>"¿Le muestro el columbario de ónix para que vea la piedra en persona?"</a:t>
             </a:r>
           </a:p>
         </p:txBody>
@@ -25892,7 +25892,7 @@
                 </a:solidFill>
                 <a:latin typeface="Montserrat"/>
               </a:rPr>
-              <a:t>«Hay opciones más baratas.» → «Sí, y con gusto se las muestro. El ónix es para quien busca algo único: una piedra natural que no se repite.»</a:t>
+              <a:t>"Hay opciones más baratas." → "Sí, y con gusto se las muestro. El ónix es para quien busca algo único: una piedra natural que no se repite."</a:t>
             </a:r>
           </a:p>
         </p:txBody>
@@ -27451,7 +27451,7 @@
                 </a:solidFill>
                 <a:latin typeface="Playfair Display"/>
               </a:rPr>
-              <a:t>«Este columbario es una obra de arte de fe: la tapa de ónix con imagen religiosa convierte el lugar de descanso de su familia en un espacio de oración y contemplación, para generaciones.»</a:t>
+              <a:t>"Este columbario es una obra de arte de fe: la tapa de ónix con imagen religiosa convierte el lugar de descanso de su familia en un espacio de oración y contemplación, para generaciones."</a:t>
             </a:r>
           </a:p>
         </p:txBody>
@@ -27832,7 +27832,7 @@
                 </a:solidFill>
                 <a:latin typeface="Montserrat"/>
               </a:rPr>
-              <a:t>«¿Reservamos hoy el espacio familiar con el precio de noviembre?»</a:t>
+              <a:t>"¿Reservamos hoy el espacio familiar con el precio de noviembre?"</a:t>
             </a:r>
           </a:p>
         </p:txBody>
@@ -28004,7 +28004,7 @@
                 </a:solidFill>
                 <a:latin typeface="Montserrat"/>
               </a:rPr>
-              <a:t>«Es muy caro.» → «Es un legado para cuatro personas, para siempre, y puede pagarse en hasta 120 meses. Es la opción más exclusiva del portafolio.»</a:t>
+              <a:t>"Es muy caro." → "Es un legado para cuatro personas, para siempre, y puede pagarse en hasta 120 meses. Es la opción más exclusiva del portafolio."</a:t>
             </a:r>
           </a:p>
         </p:txBody>
@@ -29619,7 +29619,7 @@
                 </a:solidFill>
                 <a:latin typeface="Playfair Display"/>
               </a:rPr>
-              <a:t>«Bella Vista resuelve en un solo paso la cremación y el lugar de descanso: un columbario de cristal en nuestro mausoleo vertical, para dos o cuatro personas, con todo el proceso incluido.»</a:t>
+              <a:t>"Bella Vista resuelve en un solo paso la cremación y el lugar de descanso: un columbario de cristal en nuestro mausoleo vertical, para dos o cuatro personas, con todo el proceso incluido."</a:t>
             </a:r>
           </a:p>
         </p:txBody>
@@ -30000,7 +30000,7 @@
                 </a:solidFill>
                 <a:latin typeface="Montserrat"/>
               </a:rPr>
-              <a:t>«¿Aprovechamos el precio de noviembre y lo dejamos resuelto hoy?»</a:t>
+              <a:t>"¿Aprovechamos el precio de noviembre y lo dejamos resuelto hoy?"</a:t>
             </a:r>
           </a:p>
         </p:txBody>
@@ -30172,7 +30172,7 @@
                 </a:solidFill>
                 <a:latin typeface="Montserrat"/>
               </a:rPr>
-              <a:t>«Prefiero un jardín.» → «Perfecto, también tenemos los Jardines de Cenizas. Bella Vista es para quien prefiere un columbario, con la cremación ya incluida.»</a:t>
+              <a:t>"Prefiero un jardín." → "Perfecto, también tenemos los Jardines de Cenizas. Bella Vista es para quien prefiere un columbario, con la cremación ya incluida."</a:t>
             </a:r>
           </a:p>
         </p:txBody>
@@ -30624,7 +30624,7 @@
                 </a:solidFill>
                 <a:latin typeface="Montserrat"/>
               </a:rPr>
-              <a:t>Una objeción no es un «no»: es una duda que aún no resolvimos.</a:t>
+              <a:t>Una objeción no es un "no": es una duda que aún no resolvimos.</a:t>
             </a:r>
           </a:p>
         </p:txBody>
@@ -31298,7 +31298,7 @@
                 </a:solidFill>
                 <a:latin typeface="Montserrat"/>
               </a:rPr>
-              <a:t>1.  «No quiero pensar en eso, es de mala suerte.»</a:t>
+              <a:t>1.  "No quiero pensar en eso, es de mala suerte."</a:t>
             </a:r>
           </a:p>
         </p:txBody>
@@ -31412,7 +31412,7 @@
                 </a:solidFill>
                 <a:latin typeface="Montserrat"/>
               </a:rPr>
-              <a:t>«Entiendo, a nadie le gusta hablar de este tema.»</a:t>
+              <a:t>"Entiendo, a nadie le gusta hablar de este tema."</a:t>
             </a:r>
           </a:p>
         </p:txBody>
@@ -31640,7 +31640,7 @@
                 </a:solidFill>
                 <a:latin typeface="Montserrat"/>
               </a:rPr>
-              <a:t>«¿Le dejo la información para que la conversen en casa?»</a:t>
+              <a:t>"¿Le dejo la información para que la conversen en casa?"</a:t>
             </a:r>
           </a:p>
         </p:txBody>
@@ -31726,7 +31726,7 @@
                 </a:solidFill>
                 <a:latin typeface="Montserrat"/>
               </a:rPr>
-              <a:t>2.  «Soy católico, la cremación no está permitida.»</a:t>
+              <a:t>2.  "Soy católico, la cremación no está permitida."</a:t>
             </a:r>
           </a:p>
         </p:txBody>
@@ -31840,7 +31840,7 @@
                 </a:solidFill>
                 <a:latin typeface="Montserrat"/>
               </a:rPr>
-              <a:t>«Su fe es muy importante y la respetamos.»</a:t>
+              <a:t>"Su fe es muy importante y la respetamos."</a:t>
             </a:r>
           </a:p>
         </p:txBody>
@@ -32068,7 +32068,7 @@
                 </a:solidFill>
                 <a:latin typeface="Montserrat"/>
               </a:rPr>
-              <a:t>«¿Le gustaría conocer el jardín y ver cómo es el lugar?»</a:t>
+              <a:t>"¿Le gustaría conocer el jardín y ver cómo es el lugar?"</a:t>
             </a:r>
           </a:p>
         </p:txBody>
@@ -32436,7 +32436,7 @@
                 </a:solidFill>
                 <a:latin typeface="Montserrat"/>
               </a:rPr>
-              <a:t>3.  «Prefiero la sepultura tradicional.»</a:t>
+              <a:t>3.  "Prefiero la sepultura tradicional."</a:t>
             </a:r>
           </a:p>
         </p:txBody>
@@ -32550,7 +32550,7 @@
                 </a:solidFill>
                 <a:latin typeface="Montserrat"/>
               </a:rPr>
-              <a:t>«Es una tradición muy valiosa.»</a:t>
+              <a:t>"Es una tradición muy valiosa."</a:t>
             </a:r>
           </a:p>
         </p:txBody>
@@ -32778,7 +32778,7 @@
                 </a:solidFill>
                 <a:latin typeface="Montserrat"/>
               </a:rPr>
-              <a:t>«¿Le muestro la diferencia de inversión entre ambas opciones?»</a:t>
+              <a:t>"¿Le muestro la diferencia de inversión entre ambas opciones?"</a:t>
             </a:r>
           </a:p>
         </p:txBody>
@@ -32864,7 +32864,7 @@
                 </a:solidFill>
                 <a:latin typeface="Montserrat"/>
               </a:rPr>
-              <a:t>4.  «Está caro.»</a:t>
+              <a:t>4.  "Está caro."</a:t>
             </a:r>
           </a:p>
         </p:txBody>
@@ -32978,7 +32978,7 @@
                 </a:solidFill>
                 <a:latin typeface="Montserrat"/>
               </a:rPr>
-              <a:t>«Comprendo, es una inversión.»</a:t>
+              <a:t>"Comprendo, es una inversión."</a:t>
             </a:r>
           </a:p>
         </p:txBody>
@@ -33206,7 +33206,7 @@
                 </a:solidFill>
                 <a:latin typeface="Montserrat"/>
               </a:rPr>
-              <a:t>«¿Le resulta más cómodo pagarlo en cuotas mensuales?»</a:t>
+              <a:t>"¿Le resulta más cómodo pagarlo en cuotas mensuales?"</a:t>
             </a:r>
           </a:p>
         </p:txBody>
@@ -33530,7 +33530,7 @@
                 </a:solidFill>
                 <a:latin typeface="Montserrat"/>
               </a:rPr>
-              <a:t>En La Auxiliadora, Hogar de las Memorias y Parque Memorial Las Colinas, empresas de Vangrupo, no vendemos nichos, parcelas ni servicios: acompañamos a las familias salvadoreñas a honrar la memoria de quienes aman. La cremación es una decisión cada vez más elegida, y nuestros nuevos jardines de cenizas responden a una pregunta que muchas familias se hacen y pocas se atreven a decir: «¿y después de la cremación, dónde las visitamos?».</a:t>
+              <a:t>En La Auxiliadora, Hogar de las Memorias y Parque Memorial Las Colinas, empresas de Vangrupo, no vendemos nichos, parcelas ni servicios: acompañamos a las familias salvadoreñas a honrar la memoria de quienes aman. La cremación es una decisión cada vez más elegida, y nuestros nuevos jardines de cenizas responden a una pregunta que muchas familias se hacen y pocas se atreven a decir: "¿y después de la cremación, dónde las visitamos?".</a:t>
             </a:r>
           </a:p>
         </p:txBody>
@@ -34313,7 +34313,7 @@
                 </a:solidFill>
                 <a:latin typeface="Montserrat"/>
               </a:rPr>
-              <a:t>Nuestra diferencia no es el precio: es la atención. Antes de cada propuesta, pregúntese: «¿esto acoge a la familia o solo cierra un negocio?».</a:t>
+              <a:t>Nuestra diferencia no es el precio: es la atención. Antes de cada propuesta, pregúntese: "¿esto acoge a la familia o solo cierra un negocio?".</a:t>
             </a:r>
           </a:p>
         </p:txBody>
@@ -34681,7 +34681,7 @@
                 </a:solidFill>
                 <a:latin typeface="Montserrat"/>
               </a:rPr>
-              <a:t>5.  «Tengo que hablarlo con mi familia.»</a:t>
+              <a:t>5.  "Tengo que hablarlo con mi familia."</a:t>
             </a:r>
           </a:p>
         </p:txBody>
@@ -34795,7 +34795,7 @@
                 </a:solidFill>
                 <a:latin typeface="Montserrat"/>
               </a:rPr>
-              <a:t>«Claro, es una decisión de familia.»</a:t>
+              <a:t>"Claro, es una decisión de familia."</a:t>
             </a:r>
           </a:p>
         </p:txBody>
@@ -35023,7 +35023,7 @@
                 </a:solidFill>
                 <a:latin typeface="Montserrat"/>
               </a:rPr>
-              <a:t>«¿Puedo llamarle el [día] para ver si quedó alguna pregunta?»</a:t>
+              <a:t>"¿Puedo llamarle el [día] para ver si quedó alguna pregunta?"</a:t>
             </a:r>
           </a:p>
         </p:txBody>
@@ -35109,7 +35109,7 @@
                 </a:solidFill>
                 <a:latin typeface="Montserrat"/>
               </a:rPr>
-              <a:t>6.  «Prefiero tener las cenizas en casa.»</a:t>
+              <a:t>6.  "Prefiero tener las cenizas en casa."</a:t>
             </a:r>
           </a:p>
         </p:txBody>
@@ -35223,7 +35223,7 @@
                 </a:solidFill>
                 <a:latin typeface="Montserrat"/>
               </a:rPr>
-              <a:t>«Es natural querer tenerlas cerca.»</a:t>
+              <a:t>"Es natural querer tenerlas cerca."</a:t>
             </a:r>
           </a:p>
         </p:txBody>
@@ -35451,7 +35451,7 @@
                 </a:solidFill>
                 <a:latin typeface="Montserrat"/>
               </a:rPr>
-              <a:t>«¿Le gustaría visitar el jardín antes de decidir?»</a:t>
+              <a:t>"¿Le gustaría visitar el jardín antes de decidir?"</a:t>
             </a:r>
           </a:p>
         </p:txBody>
@@ -35819,7 +35819,7 @@
                 </a:solidFill>
                 <a:latin typeface="Montserrat"/>
               </a:rPr>
-              <a:t>7.  «¿Por qué pagar mantenimiento cada año?»</a:t>
+              <a:t>7.  "¿Por qué pagar mantenimiento cada año?"</a:t>
             </a:r>
           </a:p>
         </p:txBody>
@@ -35933,7 +35933,7 @@
                 </a:solidFill>
                 <a:latin typeface="Montserrat"/>
               </a:rPr>
-              <a:t>«Es una pregunta muy válida.»</a:t>
+              <a:t>"Es una pregunta muy válida."</a:t>
             </a:r>
           </a:p>
         </p:txBody>
@@ -36161,7 +36161,7 @@
                 </a:solidFill>
                 <a:latin typeface="Montserrat"/>
               </a:rPr>
-              <a:t>«¿Le explico qué incluye el cuidado del jardín?»</a:t>
+              <a:t>"¿Le explico qué incluye el cuidado del jardín?"</a:t>
             </a:r>
           </a:p>
         </p:txBody>
@@ -36247,7 +36247,7 @@
                 </a:solidFill>
                 <a:latin typeface="Montserrat"/>
               </a:rPr>
-              <a:t>8.  «No confío en estos planes.»</a:t>
+              <a:t>8.  "No confío en estos planes."</a:t>
             </a:r>
           </a:p>
         </p:txBody>
@@ -36361,7 +36361,7 @@
                 </a:solidFill>
                 <a:latin typeface="Montserrat"/>
               </a:rPr>
-              <a:t>«Es una preocupación válida.»</a:t>
+              <a:t>"Es una preocupación válida."</a:t>
             </a:r>
           </a:p>
         </p:txBody>
@@ -36589,7 +36589,7 @@
                 </a:solidFill>
                 <a:latin typeface="Montserrat"/>
               </a:rPr>
-              <a:t>«¿Agendamos una visita sin compromiso?»</a:t>
+              <a:t>"¿Agendamos una visita sin compromiso?"</a:t>
             </a:r>
           </a:p>
         </p:txBody>
@@ -43375,7 +43375,7 @@
                 </a:solidFill>
                 <a:latin typeface="Montserrat"/>
               </a:rPr>
-              <a:t>Presentación «Jardines de Cenizas»</a:t>
+              <a:t>Presentación "Jardines de Cenizas"</a:t>
             </a:r>
           </a:p>
           <a:p>
@@ -44165,7 +44165,7 @@
                 </a:solidFill>
                 <a:latin typeface="Playfair Display"/>
               </a:rPr>
-              <a:t>«Cada familia que atendemos recordará cómo la tratamos en uno de los momentos más sensibles de su vida. Ese es nuestro verdadero producto.»</a:t>
+              <a:t>"Cada familia que atendemos recordará cómo la tratamos en uno de los momentos más sensibles de su vida. Ese es nuestro verdadero producto."</a:t>
             </a:r>
           </a:p>
         </p:txBody>
@@ -44793,7 +44793,7 @@
                 </a:solidFill>
                 <a:latin typeface="Montserrat"/>
               </a:rPr>
-              <a:t>En el momento de la pérdida. Aquí no se «vende»: se acoge, se informa con calma y se resuelve con agilidad y respeto.</a:t>
+              <a:t>En el momento de la pérdida. Aquí no se "vende": se acoge, se informa con calma y se resuelve con agilidad y respeto.</a:t>
             </a:r>
           </a:p>
         </p:txBody>

</xml_diff>

<commit_message>
Comisiones: Política 2026 aprobada (1 venta 8%, 2 ventas 10%, 3+ 12%)
Reemplaza la comisión única de 8% en el playbook (docx, Google Docs, pptx
horizontal y vertical), la figura de comisiones y la pestaña de comisiones
de la Ficha Técnica.

Co-Authored-By: Claude Opus 5.5 <noreply@anthropic.com>
Claude-Session: https://claude.ai/code/session_0111i7vn9WWo4QxCQbucWbrF
</commit_message>
<xml_diff>
--- a/playbook/salida/Playbook_Comercial_Cremacion_Vangrupo.pptx
+++ b/playbook/salida/Playbook_Comercial_Cremacion_Vangrupo.pptx
@@ -13264,7 +13264,7 @@
                 </a:solidFill>
                 <a:latin typeface="Montserrat"/>
               </a:rPr>
-              <a:t>Política de comisiones: 8% en todos los productos. Confirmar con el Gerente Comercial antes de aplicar.</a:t>
+              <a:t>Política de comisiones 2026 (aprobada): 1 venta en el mes = 8%, 2 ventas = 10%, 3 o más = 12% sobre la facturación.</a:t>
             </a:r>
           </a:p>
           <a:p>
@@ -14214,7 +14214,7 @@
                 </a:solidFill>
                 <a:latin typeface="Montserrat"/>
               </a:rPr>
-              <a:t>Política de comisiones</a:t>
+              <a:t>Política de comisiones 2026</a:t>
             </a:r>
           </a:p>
         </p:txBody>
@@ -40091,7 +40091,7 @@
                 </a:solidFill>
                 <a:latin typeface="Playfair Display"/>
               </a:rPr>
-              <a:t>Política de comisiones</a:t>
+              <a:t>Política de comisiones 2026</a:t>
             </a:r>
           </a:p>
         </p:txBody>
@@ -40373,7 +40373,7 @@
                 </a:solidFill>
                 <a:latin typeface="Montserrat"/>
               </a:rPr>
-              <a:t>07 · POLÍTICA DE COMISIONES</a:t>
+              <a:t>07 · POLÍTICA DE COMISIONES 2026</a:t>
             </a:r>
           </a:p>
         </p:txBody>
@@ -40415,7 +40415,7 @@
                 </a:solidFill>
                 <a:latin typeface="Playfair Display"/>
               </a:rPr>
-              <a:t>Comisión única de 8%</a:t>
+              <a:t>Comisión por cantidad de ventas: 8% · 10% · 12%</a:t>
             </a:r>
           </a:p>
         </p:txBody>
@@ -40501,7 +40501,7 @@
                 </a:solidFill>
                 <a:latin typeface="Montserrat"/>
               </a:rPr>
-              <a:t>Sobre el precio sin IVA. Confirmar con la Gerencia Comercial antes de aplicar.</a:t>
+              <a:t>Según la cantidad de ventas del mes, sobre toda la facturación sin IVA.</a:t>
             </a:r>
           </a:p>
         </p:txBody>
@@ -40522,8 +40522,8 @@
         </p:blipFill>
         <p:spPr>
           <a:xfrm>
-            <a:off x="548640" y="2951226"/>
-            <a:ext cx="6035040" cy="1961388"/>
+            <a:off x="548640" y="3290697"/>
+            <a:ext cx="6035040" cy="1282446"/>
           </a:xfrm>
           <a:prstGeom prst="rect">
             <a:avLst/>
@@ -40618,7 +40618,7 @@
                 </a:solidFill>
                 <a:latin typeface="Montserrat"/>
               </a:rPr>
-              <a:t>Base de cálculo: valor efectivamente cobrado al cliente, sin IVA (13%).</a:t>
+              <a:t>1 venta en el mes = 8%; 2 ventas = 10%; 3 o más = 12%, sobre toda la facturación del mes.</a:t>
             </a:r>
           </a:p>
           <a:p>
@@ -40646,7 +40646,7 @@
                 </a:solidFill>
                 <a:latin typeface="Montserrat"/>
               </a:rPr>
-              <a:t>Comisión única de 8% para todos los productos.</a:t>
+              <a:t>Cuenta cualquier producto de cremación (nuevos y columbarios): cada contrato es 1 venta.</a:t>
             </a:r>
           </a:p>
           <a:p>
@@ -40674,7 +40674,7 @@
                 </a:solidFill>
                 <a:latin typeface="Montserrat"/>
               </a:rPr>
-              <a:t>No generan comisión: cuotas de mantenimiento anual (US$ 15 / US$ 24).</a:t>
+              <a:t>Base de cálculo: facturación sin IVA (13%), neta de descuentos; se paga sobre lo cobrado.</a:t>
             </a:r>
           </a:p>
           <a:p>
@@ -40702,7 +40702,7 @@
                 </a:solidFill>
                 <a:latin typeface="Montserrat"/>
               </a:rPr>
-              <a:t>Bono de venta combinada: US$ 15 al vender la Solución Modular junto con cualquier jardín.</a:t>
+              <a:t>Mismo criterio para call center, contratados y freelancers. Sin bonos adicionales.</a:t>
             </a:r>
           </a:p>
           <a:p>
@@ -40730,7 +40730,7 @@
                 </a:solidFill>
                 <a:latin typeface="Montserrat"/>
               </a:rPr>
-              <a:t>Acelerador Día de los Muertos (opcional): +2 pp en Individual y Ecológico hasta el 30/11/2026.</a:t>
+              <a:t>Venta compartida (call center agenda, otro cierra): 1 venta para ambos; comisión 30% / 70%.</a:t>
             </a:r>
           </a:p>
           <a:p>
@@ -40758,7 +40758,7 @@
                 </a:solidFill>
                 <a:latin typeface="Montserrat"/>
               </a:rPr>
-              <a:t>Estorno: la comisión se descuenta de los pagos siguientes al asesor.</a:t>
+              <a:t>No cuentan ni comisionan: cuotas de mantenimiento anual (US$ 15 / US$ 24).</a:t>
             </a:r>
           </a:p>
           <a:p>
@@ -40786,7 +40786,7 @@
                 </a:solidFill>
                 <a:latin typeface="Montserrat"/>
               </a:rPr>
-              <a:t>Portafolio existente (columbarios): la comisión se definirá en un sistema propio, en preparación.</a:t>
+              <a:t>Estorno: la comisión se descuenta de los pagos siguientes al asesor; ventas anuladas no cuentan.</a:t>
             </a:r>
           </a:p>
         </p:txBody>
@@ -41068,7 +41068,7 @@
                 </a:solidFill>
                 <a:latin typeface="Montserrat"/>
               </a:rPr>
-              <a:t>07 · POLÍTICA DE COMISIONES</a:t>
+              <a:t>07 · POLÍTICA DE COMISIONES 2026</a:t>
             </a:r>
           </a:p>
         </p:txBody>
@@ -41110,7 +41110,7 @@
                 </a:solidFill>
                 <a:latin typeface="Playfair Display"/>
               </a:rPr>
-              <a:t>Cuándo se paga y cuándo se descuenta</a:t>
+              <a:t>Escala, pago y estorno</a:t>
             </a:r>
           </a:p>
         </p:txBody>
@@ -41169,7 +41169,7 @@
         </p:nvGraphicFramePr>
         <p:xfrm>
           <a:off x="548640" y="1645920"/>
-          <a:ext cx="11094413" cy="4389120"/>
+          <a:ext cx="11094413" cy="1828800"/>
         </p:xfrm>
         <a:graphic>
           <a:graphicData uri="http://schemas.openxmlformats.org/drawingml/2006/table">
@@ -41178,13 +41178,12 @@
                 <a:tableStyleId>{5C22544A-7EE6-4342-B048-85BDC9FD1C3A}</a:tableStyleId>
               </a:tblPr>
               <a:tblGrid>
-                <a:gridCol w="2326248"/>
-                <a:gridCol w="715768"/>
-                <a:gridCol w="1610479"/>
-                <a:gridCol w="4115670"/>
-                <a:gridCol w="2326248"/>
+                <a:gridCol w="2600253"/>
+                <a:gridCol w="1906852"/>
+                <a:gridCol w="3813705"/>
+                <a:gridCol w="2773603"/>
               </a:tblGrid>
-              <a:tr h="548640">
+              <a:tr h="457200">
                 <a:tc>
                   <a:txBody>
                     <a:bodyPr wrap="square"/>
@@ -41197,7 +41196,7 @@
                           </a:solidFill>
                           <a:latin typeface="Montserrat"/>
                         </a:rPr>
-                        <a:t>Producto</a:t>
+                        <a:t>Ventas en el mes</a:t>
                       </a:r>
                     </a:p>
                   </a:txBody>
@@ -41219,7 +41218,7 @@
                           </a:solidFill>
                           <a:latin typeface="Montserrat"/>
                         </a:rPr>
-                        <a:t>%</a:t>
+                        <a:t>% comisión</a:t>
                       </a:r>
                     </a:p>
                   </a:txBody>
@@ -41241,7 +41240,350 @@
                           </a:solidFill>
                           <a:latin typeface="Montserrat"/>
                         </a:rPr>
-                        <a:t>Comisión (sin IVA)</a:t>
+                        <a:t>Ejemplo: facturación (Solución Modular)</a:t>
+                      </a:r>
+                    </a:p>
+                  </a:txBody>
+                  <a:tcPr marL="73152" marR="73152" marT="36576" marB="36576" anchor="ctr">
+                    <a:solidFill>
+                      <a:srgbClr val="5B3F80"/>
+                    </a:solidFill>
+                  </a:tcPr>
+                </a:tc>
+                <a:tc>
+                  <a:txBody>
+                    <a:bodyPr wrap="square"/>
+                    <a:lstStyle/>
+                    <a:p>
+                      <a:r>
+                        <a:rPr sz="1200" b="1">
+                          <a:solidFill>
+                            <a:srgbClr val="FFFFFF"/>
+                          </a:solidFill>
+                          <a:latin typeface="Montserrat"/>
+                        </a:rPr>
+                        <a:t>Comisión del ejemplo</a:t>
+                      </a:r>
+                    </a:p>
+                  </a:txBody>
+                  <a:tcPr marL="73152" marR="73152" marT="36576" marB="36576" anchor="ctr">
+                    <a:solidFill>
+                      <a:srgbClr val="5B3F80"/>
+                    </a:solidFill>
+                  </a:tcPr>
+                </a:tc>
+              </a:tr>
+              <a:tr h="457200">
+                <a:tc>
+                  <a:txBody>
+                    <a:bodyPr wrap="square"/>
+                    <a:lstStyle/>
+                    <a:p>
+                      <a:r>
+                        <a:rPr sz="1200" b="1">
+                          <a:solidFill>
+                            <a:srgbClr val="5B3F80"/>
+                          </a:solidFill>
+                          <a:latin typeface="Montserrat"/>
+                        </a:rPr>
+                        <a:t>1 venta</a:t>
+                      </a:r>
+                    </a:p>
+                  </a:txBody>
+                  <a:tcPr marL="73152" marR="73152" marT="36576" marB="36576" anchor="ctr">
+                    <a:solidFill>
+                      <a:srgbClr val="FFFFFF"/>
+                    </a:solidFill>
+                  </a:tcPr>
+                </a:tc>
+                <a:tc>
+                  <a:txBody>
+                    <a:bodyPr wrap="square"/>
+                    <a:lstStyle/>
+                    <a:p>
+                      <a:r>
+                        <a:rPr sz="1200" b="0">
+                          <a:solidFill>
+                            <a:srgbClr val="2E2A36"/>
+                          </a:solidFill>
+                          <a:latin typeface="Montserrat"/>
+                        </a:rPr>
+                        <a:t>8%</a:t>
+                      </a:r>
+                    </a:p>
+                  </a:txBody>
+                  <a:tcPr marL="73152" marR="73152" marT="36576" marB="36576" anchor="ctr">
+                    <a:solidFill>
+                      <a:srgbClr val="FFFFFF"/>
+                    </a:solidFill>
+                  </a:tcPr>
+                </a:tc>
+                <a:tc>
+                  <a:txBody>
+                    <a:bodyPr wrap="square"/>
+                    <a:lstStyle/>
+                    <a:p>
+                      <a:r>
+                        <a:rPr sz="1200" b="0">
+                          <a:solidFill>
+                            <a:srgbClr val="2E2A36"/>
+                          </a:solidFill>
+                          <a:latin typeface="Montserrat"/>
+                        </a:rPr>
+                        <a:t>US$ 885</a:t>
+                      </a:r>
+                    </a:p>
+                  </a:txBody>
+                  <a:tcPr marL="73152" marR="73152" marT="36576" marB="36576" anchor="ctr">
+                    <a:solidFill>
+                      <a:srgbClr val="FFFFFF"/>
+                    </a:solidFill>
+                  </a:tcPr>
+                </a:tc>
+                <a:tc>
+                  <a:txBody>
+                    <a:bodyPr wrap="square"/>
+                    <a:lstStyle/>
+                    <a:p>
+                      <a:r>
+                        <a:rPr sz="1200" b="0">
+                          <a:solidFill>
+                            <a:srgbClr val="2E2A36"/>
+                          </a:solidFill>
+                          <a:latin typeface="Montserrat"/>
+                        </a:rPr>
+                        <a:t>US$ 70,80</a:t>
+                      </a:r>
+                    </a:p>
+                  </a:txBody>
+                  <a:tcPr marL="73152" marR="73152" marT="36576" marB="36576" anchor="ctr">
+                    <a:solidFill>
+                      <a:srgbClr val="FFFFFF"/>
+                    </a:solidFill>
+                  </a:tcPr>
+                </a:tc>
+              </a:tr>
+              <a:tr h="457200">
+                <a:tc>
+                  <a:txBody>
+                    <a:bodyPr wrap="square"/>
+                    <a:lstStyle/>
+                    <a:p>
+                      <a:r>
+                        <a:rPr sz="1200" b="1">
+                          <a:solidFill>
+                            <a:srgbClr val="5B3F80"/>
+                          </a:solidFill>
+                          <a:latin typeface="Montserrat"/>
+                        </a:rPr>
+                        <a:t>2 ventas</a:t>
+                      </a:r>
+                    </a:p>
+                  </a:txBody>
+                  <a:tcPr marL="73152" marR="73152" marT="36576" marB="36576" anchor="ctr">
+                    <a:solidFill>
+                      <a:srgbClr val="F5F2F8"/>
+                    </a:solidFill>
+                  </a:tcPr>
+                </a:tc>
+                <a:tc>
+                  <a:txBody>
+                    <a:bodyPr wrap="square"/>
+                    <a:lstStyle/>
+                    <a:p>
+                      <a:r>
+                        <a:rPr sz="1200" b="0">
+                          <a:solidFill>
+                            <a:srgbClr val="2E2A36"/>
+                          </a:solidFill>
+                          <a:latin typeface="Montserrat"/>
+                        </a:rPr>
+                        <a:t>10%</a:t>
+                      </a:r>
+                    </a:p>
+                  </a:txBody>
+                  <a:tcPr marL="73152" marR="73152" marT="36576" marB="36576" anchor="ctr">
+                    <a:solidFill>
+                      <a:srgbClr val="F5F2F8"/>
+                    </a:solidFill>
+                  </a:tcPr>
+                </a:tc>
+                <a:tc>
+                  <a:txBody>
+                    <a:bodyPr wrap="square"/>
+                    <a:lstStyle/>
+                    <a:p>
+                      <a:r>
+                        <a:rPr sz="1200" b="0">
+                          <a:solidFill>
+                            <a:srgbClr val="2E2A36"/>
+                          </a:solidFill>
+                          <a:latin typeface="Montserrat"/>
+                        </a:rPr>
+                        <a:t>US$ 1.770</a:t>
+                      </a:r>
+                    </a:p>
+                  </a:txBody>
+                  <a:tcPr marL="73152" marR="73152" marT="36576" marB="36576" anchor="ctr">
+                    <a:solidFill>
+                      <a:srgbClr val="F5F2F8"/>
+                    </a:solidFill>
+                  </a:tcPr>
+                </a:tc>
+                <a:tc>
+                  <a:txBody>
+                    <a:bodyPr wrap="square"/>
+                    <a:lstStyle/>
+                    <a:p>
+                      <a:r>
+                        <a:rPr sz="1200" b="0">
+                          <a:solidFill>
+                            <a:srgbClr val="2E2A36"/>
+                          </a:solidFill>
+                          <a:latin typeface="Montserrat"/>
+                        </a:rPr>
+                        <a:t>US$ 177,00</a:t>
+                      </a:r>
+                    </a:p>
+                  </a:txBody>
+                  <a:tcPr marL="73152" marR="73152" marT="36576" marB="36576" anchor="ctr">
+                    <a:solidFill>
+                      <a:srgbClr val="F5F2F8"/>
+                    </a:solidFill>
+                  </a:tcPr>
+                </a:tc>
+              </a:tr>
+              <a:tr h="457200">
+                <a:tc>
+                  <a:txBody>
+                    <a:bodyPr wrap="square"/>
+                    <a:lstStyle/>
+                    <a:p>
+                      <a:r>
+                        <a:rPr sz="1200" b="1">
+                          <a:solidFill>
+                            <a:srgbClr val="5B3F80"/>
+                          </a:solidFill>
+                          <a:latin typeface="Montserrat"/>
+                        </a:rPr>
+                        <a:t>3 ventas o más</a:t>
+                      </a:r>
+                    </a:p>
+                  </a:txBody>
+                  <a:tcPr marL="73152" marR="73152" marT="36576" marB="36576" anchor="ctr">
+                    <a:solidFill>
+                      <a:srgbClr val="FFFFFF"/>
+                    </a:solidFill>
+                  </a:tcPr>
+                </a:tc>
+                <a:tc>
+                  <a:txBody>
+                    <a:bodyPr wrap="square"/>
+                    <a:lstStyle/>
+                    <a:p>
+                      <a:r>
+                        <a:rPr sz="1200" b="0">
+                          <a:solidFill>
+                            <a:srgbClr val="2E2A36"/>
+                          </a:solidFill>
+                          <a:latin typeface="Montserrat"/>
+                        </a:rPr>
+                        <a:t>12%</a:t>
+                      </a:r>
+                    </a:p>
+                  </a:txBody>
+                  <a:tcPr marL="73152" marR="73152" marT="36576" marB="36576" anchor="ctr">
+                    <a:solidFill>
+                      <a:srgbClr val="FFFFFF"/>
+                    </a:solidFill>
+                  </a:tcPr>
+                </a:tc>
+                <a:tc>
+                  <a:txBody>
+                    <a:bodyPr wrap="square"/>
+                    <a:lstStyle/>
+                    <a:p>
+                      <a:r>
+                        <a:rPr sz="1200" b="0">
+                          <a:solidFill>
+                            <a:srgbClr val="2E2A36"/>
+                          </a:solidFill>
+                          <a:latin typeface="Montserrat"/>
+                        </a:rPr>
+                        <a:t>US$ 2.655</a:t>
+                      </a:r>
+                    </a:p>
+                  </a:txBody>
+                  <a:tcPr marL="73152" marR="73152" marT="36576" marB="36576" anchor="ctr">
+                    <a:solidFill>
+                      <a:srgbClr val="FFFFFF"/>
+                    </a:solidFill>
+                  </a:tcPr>
+                </a:tc>
+                <a:tc>
+                  <a:txBody>
+                    <a:bodyPr wrap="square"/>
+                    <a:lstStyle/>
+                    <a:p>
+                      <a:r>
+                        <a:rPr sz="1200" b="0">
+                          <a:solidFill>
+                            <a:srgbClr val="2E2A36"/>
+                          </a:solidFill>
+                          <a:latin typeface="Montserrat"/>
+                        </a:rPr>
+                        <a:t>US$ 318,60</a:t>
+                      </a:r>
+                    </a:p>
+                  </a:txBody>
+                  <a:tcPr marL="73152" marR="73152" marT="36576" marB="36576" anchor="ctr">
+                    <a:solidFill>
+                      <a:srgbClr val="FFFFFF"/>
+                    </a:solidFill>
+                  </a:tcPr>
+                </a:tc>
+              </a:tr>
+            </a:tbl>
+          </a:graphicData>
+        </a:graphic>
+      </p:graphicFrame>
+      <p:graphicFrame>
+        <p:nvGraphicFramePr>
+          <p:cNvPr id="7" name="Table 6"/>
+          <p:cNvGraphicFramePr>
+            <a:graphicFrameLocks noGrp="1"/>
+          </p:cNvGraphicFramePr>
+          <p:nvPr/>
+        </p:nvGraphicFramePr>
+        <p:xfrm>
+          <a:off x="548640" y="3794760"/>
+          <a:ext cx="11094413" cy="2286000"/>
+        </p:xfrm>
+        <a:graphic>
+          <a:graphicData uri="http://schemas.openxmlformats.org/drawingml/2006/table">
+            <a:tbl>
+              <a:tblPr firstRow="1" bandRow="1">
+                <a:tableStyleId>{5C22544A-7EE6-4342-B048-85BDC9FD1C3A}</a:tableStyleId>
+              </a:tblPr>
+              <a:tblGrid>
+                <a:gridCol w="3120304"/>
+                <a:gridCol w="5027156"/>
+                <a:gridCol w="2946953"/>
+              </a:tblGrid>
+              <a:tr h="457200">
+                <a:tc>
+                  <a:txBody>
+                    <a:bodyPr wrap="square"/>
+                    <a:lstStyle/>
+                    <a:p>
+                      <a:r>
+                        <a:rPr sz="1200" b="1">
+                          <a:solidFill>
+                            <a:srgbClr val="FFFFFF"/>
+                          </a:solidFill>
+                          <a:latin typeface="Montserrat"/>
+                        </a:rPr>
+                        <a:t>Producto</a:t>
                       </a:r>
                     </a:p>
                   </a:txBody>
@@ -41296,7 +41638,7 @@
                   </a:tcPr>
                 </a:tc>
               </a:tr>
-              <a:tr h="548640">
+              <a:tr h="457200">
                 <a:tc>
                   <a:txBody>
                     <a:bodyPr wrap="square"/>
@@ -41310,50 +41652,6 @@
                           <a:latin typeface="Montserrat"/>
                         </a:rPr>
                         <a:t>Solución Modular</a:t>
-                      </a:r>
-                    </a:p>
-                  </a:txBody>
-                  <a:tcPr marL="73152" marR="73152" marT="36576" marB="36576" anchor="ctr">
-                    <a:solidFill>
-                      <a:srgbClr val="FFFFFF"/>
-                    </a:solidFill>
-                  </a:tcPr>
-                </a:tc>
-                <a:tc>
-                  <a:txBody>
-                    <a:bodyPr wrap="square"/>
-                    <a:lstStyle/>
-                    <a:p>
-                      <a:r>
-                        <a:rPr sz="1200" b="0">
-                          <a:solidFill>
-                            <a:srgbClr val="2E2A36"/>
-                          </a:solidFill>
-                          <a:latin typeface="Montserrat"/>
-                        </a:rPr>
-                        <a:t>8%</a:t>
-                      </a:r>
-                    </a:p>
-                  </a:txBody>
-                  <a:tcPr marL="73152" marR="73152" marT="36576" marB="36576" anchor="ctr">
-                    <a:solidFill>
-                      <a:srgbClr val="FFFFFF"/>
-                    </a:solidFill>
-                  </a:tcPr>
-                </a:tc>
-                <a:tc>
-                  <a:txBody>
-                    <a:bodyPr wrap="square"/>
-                    <a:lstStyle/>
-                    <a:p>
-                      <a:r>
-                        <a:rPr sz="1200" b="0">
-                          <a:solidFill>
-                            <a:srgbClr val="2E2A36"/>
-                          </a:solidFill>
-                          <a:latin typeface="Montserrat"/>
-                        </a:rPr>
-                        <a:t>US$ 70,80</a:t>
                       </a:r>
                     </a:p>
                   </a:txBody>
@@ -41408,7 +41706,7 @@
                   </a:tcPr>
                 </a:tc>
               </a:tr>
-              <a:tr h="548640">
+              <a:tr h="457200">
                 <a:tc>
                   <a:txBody>
                     <a:bodyPr wrap="square"/>
@@ -41421,51 +41719,7 @@
                           </a:solidFill>
                           <a:latin typeface="Montserrat"/>
                         </a:rPr>
-                        <a:t>Jardín Individual</a:t>
-                      </a:r>
-                    </a:p>
-                  </a:txBody>
-                  <a:tcPr marL="73152" marR="73152" marT="36576" marB="36576" anchor="ctr">
-                    <a:solidFill>
-                      <a:srgbClr val="F5F2F8"/>
-                    </a:solidFill>
-                  </a:tcPr>
-                </a:tc>
-                <a:tc>
-                  <a:txBody>
-                    <a:bodyPr wrap="square"/>
-                    <a:lstStyle/>
-                    <a:p>
-                      <a:r>
-                        <a:rPr sz="1200" b="0">
-                          <a:solidFill>
-                            <a:srgbClr val="2E2A36"/>
-                          </a:solidFill>
-                          <a:latin typeface="Montserrat"/>
-                        </a:rPr>
-                        <a:t>8%</a:t>
-                      </a:r>
-                    </a:p>
-                  </a:txBody>
-                  <a:tcPr marL="73152" marR="73152" marT="36576" marB="36576" anchor="ctr">
-                    <a:solidFill>
-                      <a:srgbClr val="F5F2F8"/>
-                    </a:solidFill>
-                  </a:tcPr>
-                </a:tc>
-                <a:tc>
-                  <a:txBody>
-                    <a:bodyPr wrap="square"/>
-                    <a:lstStyle/>
-                    <a:p>
-                      <a:r>
-                        <a:rPr sz="1200" b="0">
-                          <a:solidFill>
-                            <a:srgbClr val="2E2A36"/>
-                          </a:solidFill>
-                          <a:latin typeface="Montserrat"/>
-                        </a:rPr>
-                        <a:t>US$ 42,48</a:t>
+                        <a:t>Jardines de Cenizas</a:t>
                       </a:r>
                     </a:p>
                   </a:txBody>
@@ -41520,7 +41774,7 @@
                   </a:tcPr>
                 </a:tc>
               </a:tr>
-              <a:tr h="548640">
+              <a:tr h="457200">
                 <a:tc>
                   <a:txBody>
                     <a:bodyPr wrap="square"/>
@@ -41533,7 +41787,7 @@
                           </a:solidFill>
                           <a:latin typeface="Montserrat"/>
                         </a:rPr>
-                        <a:t>Jardín Familiar</a:t>
+                        <a:t>Jardín de Mascotas</a:t>
                       </a:r>
                     </a:p>
                   </a:txBody>
@@ -41555,51 +41809,7 @@
                           </a:solidFill>
                           <a:latin typeface="Montserrat"/>
                         </a:rPr>
-                        <a:t>8%</a:t>
-                      </a:r>
-                    </a:p>
-                  </a:txBody>
-                  <a:tcPr marL="73152" marR="73152" marT="36576" marB="36576" anchor="ctr">
-                    <a:solidFill>
-                      <a:srgbClr val="FFFFFF"/>
-                    </a:solidFill>
-                  </a:tcPr>
-                </a:tc>
-                <a:tc>
-                  <a:txBody>
-                    <a:bodyPr wrap="square"/>
-                    <a:lstStyle/>
-                    <a:p>
-                      <a:r>
-                        <a:rPr sz="1200" b="0">
-                          <a:solidFill>
-                            <a:srgbClr val="2E2A36"/>
-                          </a:solidFill>
-                          <a:latin typeface="Montserrat"/>
-                        </a:rPr>
-                        <a:t>US$ 141,59</a:t>
-                      </a:r>
-                    </a:p>
-                  </a:txBody>
-                  <a:tcPr marL="73152" marR="73152" marT="36576" marB="36576" anchor="ctr">
-                    <a:solidFill>
-                      <a:srgbClr val="FFFFFF"/>
-                    </a:solidFill>
-                  </a:tcPr>
-                </a:tc>
-                <a:tc>
-                  <a:txBody>
-                    <a:bodyPr wrap="square"/>
-                    <a:lstStyle/>
-                    <a:p>
-                      <a:r>
-                        <a:rPr sz="1200" b="0">
-                          <a:solidFill>
-                            <a:srgbClr val="2E2A36"/>
-                          </a:solidFill>
-                          <a:latin typeface="Montserrat"/>
-                        </a:rPr>
-                        <a:t>Contado: mes siguiente · Financiado: proporcional a lo cobrado</a:t>
+                        <a:t>Mes siguiente al pago</a:t>
                       </a:r>
                     </a:p>
                   </a:txBody>
@@ -41632,7 +41842,7 @@
                   </a:tcPr>
                 </a:tc>
               </a:tr>
-              <a:tr h="548640">
+              <a:tr h="457200">
                 <a:tc>
                   <a:txBody>
                     <a:bodyPr wrap="square"/>
@@ -41645,51 +41855,7 @@
                           </a:solidFill>
                           <a:latin typeface="Montserrat"/>
                         </a:rPr>
-                        <a:t>Jardín Ecológico</a:t>
-                      </a:r>
-                    </a:p>
-                  </a:txBody>
-                  <a:tcPr marL="73152" marR="73152" marT="36576" marB="36576" anchor="ctr">
-                    <a:solidFill>
-                      <a:srgbClr val="F5F2F8"/>
-                    </a:solidFill>
-                  </a:tcPr>
-                </a:tc>
-                <a:tc>
-                  <a:txBody>
-                    <a:bodyPr wrap="square"/>
-                    <a:lstStyle/>
-                    <a:p>
-                      <a:r>
-                        <a:rPr sz="1200" b="0">
-                          <a:solidFill>
-                            <a:srgbClr val="2E2A36"/>
-                          </a:solidFill>
-                          <a:latin typeface="Montserrat"/>
-                        </a:rPr>
-                        <a:t>8%</a:t>
-                      </a:r>
-                    </a:p>
-                  </a:txBody>
-                  <a:tcPr marL="73152" marR="73152" marT="36576" marB="36576" anchor="ctr">
-                    <a:solidFill>
-                      <a:srgbClr val="F5F2F8"/>
-                    </a:solidFill>
-                  </a:tcPr>
-                </a:tc>
-                <a:tc>
-                  <a:txBody>
-                    <a:bodyPr wrap="square"/>
-                    <a:lstStyle/>
-                    <a:p>
-                      <a:r>
-                        <a:rPr sz="1200" b="0">
-                          <a:solidFill>
-                            <a:srgbClr val="2E2A36"/>
-                          </a:solidFill>
-                          <a:latin typeface="Montserrat"/>
-                        </a:rPr>
-                        <a:t>US$ 53,10</a:t>
+                        <a:t>Columbarios (portafolio existente)</a:t>
                       </a:r>
                     </a:p>
                   </a:txBody>
@@ -41744,349 +41910,13 @@
                   </a:tcPr>
                 </a:tc>
               </a:tr>
-              <a:tr h="548640">
-                <a:tc>
-                  <a:txBody>
-                    <a:bodyPr wrap="square"/>
-                    <a:lstStyle/>
-                    <a:p>
-                      <a:r>
-                        <a:rPr sz="1200" b="1">
-                          <a:solidFill>
-                            <a:srgbClr val="5B3F80"/>
-                          </a:solidFill>
-                          <a:latin typeface="Montserrat"/>
-                        </a:rPr>
-                        <a:t>Mascotas · solo espacio</a:t>
-                      </a:r>
-                    </a:p>
-                  </a:txBody>
-                  <a:tcPr marL="73152" marR="73152" marT="36576" marB="36576" anchor="ctr">
-                    <a:solidFill>
-                      <a:srgbClr val="FFFFFF"/>
-                    </a:solidFill>
-                  </a:tcPr>
-                </a:tc>
-                <a:tc>
-                  <a:txBody>
-                    <a:bodyPr wrap="square"/>
-                    <a:lstStyle/>
-                    <a:p>
-                      <a:r>
-                        <a:rPr sz="1200" b="0">
-                          <a:solidFill>
-                            <a:srgbClr val="2E2A36"/>
-                          </a:solidFill>
-                          <a:latin typeface="Montserrat"/>
-                        </a:rPr>
-                        <a:t>8%</a:t>
-                      </a:r>
-                    </a:p>
-                  </a:txBody>
-                  <a:tcPr marL="73152" marR="73152" marT="36576" marB="36576" anchor="ctr">
-                    <a:solidFill>
-                      <a:srgbClr val="FFFFFF"/>
-                    </a:solidFill>
-                  </a:tcPr>
-                </a:tc>
-                <a:tc>
-                  <a:txBody>
-                    <a:bodyPr wrap="square"/>
-                    <a:lstStyle/>
-                    <a:p>
-                      <a:r>
-                        <a:rPr sz="1200" b="0">
-                          <a:solidFill>
-                            <a:srgbClr val="2E2A36"/>
-                          </a:solidFill>
-                          <a:latin typeface="Montserrat"/>
-                        </a:rPr>
-                        <a:t>US$ 28,32</a:t>
-                      </a:r>
-                    </a:p>
-                  </a:txBody>
-                  <a:tcPr marL="73152" marR="73152" marT="36576" marB="36576" anchor="ctr">
-                    <a:solidFill>
-                      <a:srgbClr val="FFFFFF"/>
-                    </a:solidFill>
-                  </a:tcPr>
-                </a:tc>
-                <a:tc>
-                  <a:txBody>
-                    <a:bodyPr wrap="square"/>
-                    <a:lstStyle/>
-                    <a:p>
-                      <a:r>
-                        <a:rPr sz="1200" b="0">
-                          <a:solidFill>
-                            <a:srgbClr val="2E2A36"/>
-                          </a:solidFill>
-                          <a:latin typeface="Montserrat"/>
-                        </a:rPr>
-                        <a:t>Mes siguiente al pago</a:t>
-                      </a:r>
-                    </a:p>
-                  </a:txBody>
-                  <a:tcPr marL="73152" marR="73152" marT="36576" marB="36576" anchor="ctr">
-                    <a:solidFill>
-                      <a:srgbClr val="FFFFFF"/>
-                    </a:solidFill>
-                  </a:tcPr>
-                </a:tc>
-                <a:tc>
-                  <a:txBody>
-                    <a:bodyPr wrap="square"/>
-                    <a:lstStyle/>
-                    <a:p>
-                      <a:r>
-                        <a:rPr sz="1200" b="0">
-                          <a:solidFill>
-                            <a:srgbClr val="2E2A36"/>
-                          </a:solidFill>
-                          <a:latin typeface="Montserrat"/>
-                        </a:rPr>
-                        <a:t>Cancelación en 90 días</a:t>
-                      </a:r>
-                    </a:p>
-                  </a:txBody>
-                  <a:tcPr marL="73152" marR="73152" marT="36576" marB="36576" anchor="ctr">
-                    <a:solidFill>
-                      <a:srgbClr val="FFFFFF"/>
-                    </a:solidFill>
-                  </a:tcPr>
-                </a:tc>
-              </a:tr>
-              <a:tr h="548640">
-                <a:tc>
-                  <a:txBody>
-                    <a:bodyPr wrap="square"/>
-                    <a:lstStyle/>
-                    <a:p>
-                      <a:r>
-                        <a:rPr sz="1200" b="1">
-                          <a:solidFill>
-                            <a:srgbClr val="5B3F80"/>
-                          </a:solidFill>
-                          <a:latin typeface="Montserrat"/>
-                        </a:rPr>
-                        <a:t>Mascotas · jardín + cremación</a:t>
-                      </a:r>
-                    </a:p>
-                  </a:txBody>
-                  <a:tcPr marL="73152" marR="73152" marT="36576" marB="36576" anchor="ctr">
-                    <a:solidFill>
-                      <a:srgbClr val="F5F2F8"/>
-                    </a:solidFill>
-                  </a:tcPr>
-                </a:tc>
-                <a:tc>
-                  <a:txBody>
-                    <a:bodyPr wrap="square"/>
-                    <a:lstStyle/>
-                    <a:p>
-                      <a:r>
-                        <a:rPr sz="1200" b="0">
-                          <a:solidFill>
-                            <a:srgbClr val="2E2A36"/>
-                          </a:solidFill>
-                          <a:latin typeface="Montserrat"/>
-                        </a:rPr>
-                        <a:t>8%</a:t>
-                      </a:r>
-                    </a:p>
-                  </a:txBody>
-                  <a:tcPr marL="73152" marR="73152" marT="36576" marB="36576" anchor="ctr">
-                    <a:solidFill>
-                      <a:srgbClr val="F5F2F8"/>
-                    </a:solidFill>
-                  </a:tcPr>
-                </a:tc>
-                <a:tc>
-                  <a:txBody>
-                    <a:bodyPr wrap="square"/>
-                    <a:lstStyle/>
-                    <a:p>
-                      <a:r>
-                        <a:rPr sz="1200" b="0">
-                          <a:solidFill>
-                            <a:srgbClr val="2E2A36"/>
-                          </a:solidFill>
-                          <a:latin typeface="Montserrat"/>
-                        </a:rPr>
-                        <a:t>US$ 38,94</a:t>
-                      </a:r>
-                    </a:p>
-                  </a:txBody>
-                  <a:tcPr marL="73152" marR="73152" marT="36576" marB="36576" anchor="ctr">
-                    <a:solidFill>
-                      <a:srgbClr val="F5F2F8"/>
-                    </a:solidFill>
-                  </a:tcPr>
-                </a:tc>
-                <a:tc>
-                  <a:txBody>
-                    <a:bodyPr wrap="square"/>
-                    <a:lstStyle/>
-                    <a:p>
-                      <a:r>
-                        <a:rPr sz="1200" b="0">
-                          <a:solidFill>
-                            <a:srgbClr val="2E2A36"/>
-                          </a:solidFill>
-                          <a:latin typeface="Montserrat"/>
-                        </a:rPr>
-                        <a:t>Mes siguiente al pago</a:t>
-                      </a:r>
-                    </a:p>
-                  </a:txBody>
-                  <a:tcPr marL="73152" marR="73152" marT="36576" marB="36576" anchor="ctr">
-                    <a:solidFill>
-                      <a:srgbClr val="F5F2F8"/>
-                    </a:solidFill>
-                  </a:tcPr>
-                </a:tc>
-                <a:tc>
-                  <a:txBody>
-                    <a:bodyPr wrap="square"/>
-                    <a:lstStyle/>
-                    <a:p>
-                      <a:r>
-                        <a:rPr sz="1200" b="0">
-                          <a:solidFill>
-                            <a:srgbClr val="2E2A36"/>
-                          </a:solidFill>
-                          <a:latin typeface="Montserrat"/>
-                        </a:rPr>
-                        <a:t>Cancelación en 90 días</a:t>
-                      </a:r>
-                    </a:p>
-                  </a:txBody>
-                  <a:tcPr marL="73152" marR="73152" marT="36576" marB="36576" anchor="ctr">
-                    <a:solidFill>
-                      <a:srgbClr val="F5F2F8"/>
-                    </a:solidFill>
-                  </a:tcPr>
-                </a:tc>
-              </a:tr>
-              <a:tr h="548640">
-                <a:tc>
-                  <a:txBody>
-                    <a:bodyPr wrap="square"/>
-                    <a:lstStyle/>
-                    <a:p>
-                      <a:r>
-                        <a:rPr sz="1200" b="1">
-                          <a:solidFill>
-                            <a:srgbClr val="5B3F80"/>
-                          </a:solidFill>
-                          <a:latin typeface="Montserrat"/>
-                        </a:rPr>
-                        <a:t>Jardín Ceremonial</a:t>
-                      </a:r>
-                    </a:p>
-                  </a:txBody>
-                  <a:tcPr marL="73152" marR="73152" marT="36576" marB="36576" anchor="ctr">
-                    <a:solidFill>
-                      <a:srgbClr val="FBF6EC"/>
-                    </a:solidFill>
-                  </a:tcPr>
-                </a:tc>
-                <a:tc>
-                  <a:txBody>
-                    <a:bodyPr wrap="square"/>
-                    <a:lstStyle/>
-                    <a:p>
-                      <a:r>
-                        <a:rPr sz="1200" b="0">
-                          <a:solidFill>
-                            <a:srgbClr val="2E2A36"/>
-                          </a:solidFill>
-                          <a:latin typeface="Montserrat"/>
-                        </a:rPr>
-                        <a:t>A definir</a:t>
-                      </a:r>
-                    </a:p>
-                  </a:txBody>
-                  <a:tcPr marL="73152" marR="73152" marT="36576" marB="36576" anchor="ctr">
-                    <a:solidFill>
-                      <a:srgbClr val="FBF6EC"/>
-                    </a:solidFill>
-                  </a:tcPr>
-                </a:tc>
-                <a:tc>
-                  <a:txBody>
-                    <a:bodyPr wrap="square"/>
-                    <a:lstStyle/>
-                    <a:p>
-                      <a:r>
-                        <a:rPr sz="1200" b="0">
-                          <a:solidFill>
-                            <a:srgbClr val="2E2A36"/>
-                          </a:solidFill>
-                          <a:latin typeface="Montserrat"/>
-                        </a:rPr>
-                        <a:t>—</a:t>
-                      </a:r>
-                    </a:p>
-                  </a:txBody>
-                  <a:tcPr marL="73152" marR="73152" marT="36576" marB="36576" anchor="ctr">
-                    <a:solidFill>
-                      <a:srgbClr val="FBF6EC"/>
-                    </a:solidFill>
-                  </a:tcPr>
-                </a:tc>
-                <a:tc>
-                  <a:txBody>
-                    <a:bodyPr wrap="square"/>
-                    <a:lstStyle/>
-                    <a:p>
-                      <a:r>
-                        <a:rPr sz="1200" b="0">
-                          <a:solidFill>
-                            <a:srgbClr val="2E2A36"/>
-                          </a:solidFill>
-                          <a:latin typeface="Montserrat"/>
-                        </a:rPr>
-                        <a:t>—</a:t>
-                      </a:r>
-                    </a:p>
-                  </a:txBody>
-                  <a:tcPr marL="73152" marR="73152" marT="36576" marB="36576" anchor="ctr">
-                    <a:solidFill>
-                      <a:srgbClr val="FBF6EC"/>
-                    </a:solidFill>
-                  </a:tcPr>
-                </a:tc>
-                <a:tc>
-                  <a:txBody>
-                    <a:bodyPr wrap="square"/>
-                    <a:lstStyle/>
-                    <a:p>
-                      <a:r>
-                        <a:rPr sz="1200" b="0">
-                          <a:solidFill>
-                            <a:srgbClr val="2E2A36"/>
-                          </a:solidFill>
-                          <a:latin typeface="Montserrat"/>
-                        </a:rPr>
-                        <a:t>—</a:t>
-                      </a:r>
-                    </a:p>
-                  </a:txBody>
-                  <a:tcPr marL="73152" marR="73152" marT="36576" marB="36576" anchor="ctr">
-                    <a:solidFill>
-                      <a:srgbClr val="FBF6EC"/>
-                    </a:solidFill>
-                  </a:tcPr>
-                </a:tc>
-              </a:tr>
             </a:tbl>
           </a:graphicData>
         </a:graphic>
       </p:graphicFrame>
       <p:sp>
         <p:nvSpPr>
-          <p:cNvPr id="7" name="TextBox 6"/>
+          <p:cNvPr id="8" name="TextBox 7"/>
           <p:cNvSpPr txBox="1"/>
           <p:nvPr/>
         </p:nvSpPr>
@@ -42128,7 +41958,7 @@
       </p:sp>
       <p:sp>
         <p:nvSpPr>
-          <p:cNvPr id="8" name="TextBox 7"/>
+          <p:cNvPr id="9" name="TextBox 8"/>
           <p:cNvSpPr txBox="1"/>
           <p:nvPr/>
         </p:nvSpPr>

</xml_diff>

<commit_message>
Comisiones: nombre "Política de comisiones de los productos de cremación"
Quita las menciones a "aprobada"/"Propuesta" y renombra la pestaña de la ficha técnica a "Política de Comisiones".

Co-Authored-By: Claude Opus 5.5 <noreply@anthropic.com>
Claude-Session: https://claude.ai/code/session_0111i7vn9WWo4QxCQbucWbrF
</commit_message>
<xml_diff>
--- a/playbook/salida/Playbook_Comercial_Cremacion_Vangrupo.pptx
+++ b/playbook/salida/Playbook_Comercial_Cremacion_Vangrupo.pptx
@@ -13264,7 +13264,7 @@
                 </a:solidFill>
                 <a:latin typeface="Montserrat"/>
               </a:rPr>
-              <a:t>Política de comisiones 2026 (aprobada): 1 venta en el mes = 8%, 2 ventas = 10%, 3 o más = 12% sobre la facturación.</a:t>
+              <a:t>Política de comisiones de los productos de cremación: 1 venta en el mes = 8%, 2 ventas = 10%, 3 o más = 12% sobre la facturación.</a:t>
             </a:r>
           </a:p>
           <a:p>
@@ -14214,7 +14214,7 @@
                 </a:solidFill>
                 <a:latin typeface="Montserrat"/>
               </a:rPr>
-              <a:t>Política de comisiones 2026</a:t>
+              <a:t>Política de comisiones de los productos de cremación</a:t>
             </a:r>
           </a:p>
         </p:txBody>
@@ -40091,7 +40091,7 @@
                 </a:solidFill>
                 <a:latin typeface="Playfair Display"/>
               </a:rPr>
-              <a:t>Política de comisiones 2026</a:t>
+              <a:t>Política de comisiones</a:t>
             </a:r>
           </a:p>
         </p:txBody>
@@ -40373,7 +40373,7 @@
                 </a:solidFill>
                 <a:latin typeface="Montserrat"/>
               </a:rPr>
-              <a:t>07 · POLÍTICA DE COMISIONES 2026</a:t>
+              <a:t>07 · COMISIONES · PRODUCTOS DE CREMACIÓN</a:t>
             </a:r>
           </a:p>
         </p:txBody>
@@ -41068,7 +41068,7 @@
                 </a:solidFill>
                 <a:latin typeface="Montserrat"/>
               </a:rPr>
-              <a:t>07 · POLÍTICA DE COMISIONES 2026</a:t>
+              <a:t>07 · COMISIONES · PRODUCTOS DE CREMACIÓN</a:t>
             </a:r>
           </a:p>
         </p:txBody>

</xml_diff>

<commit_message>
Playbook: todo el portafolio de cremación y sin producto por equipo
Incluye los columbarios existentes en la introducción, perfiles, objeciones, herramientas y checklist; la sección de equipos ya no asigna productos por canal.

Co-Authored-By: Claude Opus 5.5 <noreply@anthropic.com>
Claude-Session: https://claude.ai/code/session_0111i7vn9WWo4QxCQbucWbrF
</commit_message>
<xml_diff>
--- a/playbook/salida/Playbook_Comercial_Cremacion_Vangrupo.pptx
+++ b/playbook/salida/Playbook_Comercial_Cremacion_Vangrupo.pptx
@@ -3311,7 +3311,7 @@
                 </a:solidFill>
                 <a:latin typeface="Playfair Display"/>
               </a:rPr>
-              <a:t>Portafolio de Cremación y Jardines de Cenizas</a:t>
+              <a:t>Portafolio de Cremación: lanzamientos y columbarios</a:t>
             </a:r>
           </a:p>
         </p:txBody>
@@ -13083,7 +13083,7 @@
                 </a:solidFill>
                 <a:latin typeface="Montserrat"/>
               </a:rPr>
-              <a:t>Este playbook es la referencia única del equipo comercial para el portafolio de cremación y jardines de cenizas. Reúne reglas, precios, discurso por producto, manejo de objeciones y política de comisiones. Se revisa cada trimestre con la Gerencia Comercial. Si algo cambia en la Ficha Técnica, este documento se actualiza.</a:t>
+              <a:t>Este playbook es la referencia única del equipo comercial para todo el portafolio de cremación: los lanzamientos de Finados (Solución Modular y jardines de cenizas) y los columbarios que ya vendemos. Reúne reglas, precios, discurso por producto, manejo de objeciones y política de comisiones. Se revisa cada trimestre con la Gerencia Comercial. Si algo cambia en la Ficha Técnica, este documento se actualiza.</a:t>
             </a:r>
           </a:p>
         </p:txBody>
@@ -31954,7 +31954,7 @@
                 </a:solidFill>
                 <a:latin typeface="Montserrat"/>
               </a:rPr>
-              <a:t>La Iglesia Católica permite la cremación desde 1963. Lo que pide es que las cenizas reposen en un lugar dedicado, como el cementerio, y no en casa ni dispersas. Nuestros jardines cumplen exactamente con eso.</a:t>
+              <a:t>La Iglesia Católica permite la cremación desde 1963. Lo que pide es que las cenizas reposen en un lugar dedicado, como el cementerio, y no en casa ni dispersas. Nuestros jardines y columbarios cumplen exactamente con eso.</a:t>
             </a:r>
           </a:p>
         </p:txBody>
@@ -33092,7 +33092,7 @@
                 </a:solidFill>
                 <a:latin typeface="Montserrat"/>
               </a:rPr>
-              <a:t>En la urgencia los costos son mayores y se pagan de golpe. Hoy fija el precio y lo paga en cuotas: la Solución Modular se paga en hasta 120 meses.</a:t>
+              <a:t>En la urgencia los costos son mayores y se pagan de golpe. Hoy fija el precio y lo paga en cuotas: la Solución Modular y los columbarios se pagan en hasta 120 meses.</a:t>
             </a:r>
           </a:p>
         </p:txBody>
@@ -33530,7 +33530,7 @@
                 </a:solidFill>
                 <a:latin typeface="Montserrat"/>
               </a:rPr>
-              <a:t>En La Auxiliadora, Hogar de las Memorias y Parque Memorial Las Colinas, empresas de Vangrupo, no vendemos nichos, parcelas ni servicios: acompañamos a las familias salvadoreñas a honrar la memoria de quienes aman. La cremación es una decisión cada vez más elegida, y nuestros nuevos jardines de cenizas responden a una pregunta que muchas familias se hacen y pocas se atreven a decir: "¿y después de la cremación, dónde las visitamos?".</a:t>
+              <a:t>En La Auxiliadora, Hogar de las Memorias y Parque Memorial Las Colinas, empresas de Vangrupo, no vendemos nichos, parcelas ni servicios: acompañamos a las familias salvadoreñas a honrar la memoria de quienes aman. La cremación es una decisión cada vez más elegida, y nuestros nuevos jardines de cenizas responden a una pregunta que muchas familias se hacen y pocas se atreven a decir: "¿y después de la cremación, dónde las visitamos?". A los nuevos jardines se suman los columbarios que ya ofrecemos en El Hogar de las Memorias y en el mausoleo Bella Vista.</a:t>
             </a:r>
           </a:p>
         </p:txBody>
@@ -33702,7 +33702,7 @@
                 </a:solidFill>
                 <a:latin typeface="Montserrat"/>
               </a:rPr>
-              <a:t>La familia tiene un sitio físico, digno y verde para visitar y recordar.</a:t>
+              <a:t>La familia tiene un sitio físico y digno para visitar y recordar: un jardín o un columbario.</a:t>
             </a:r>
           </a:p>
         </p:txBody>
@@ -35337,7 +35337,7 @@
                 </a:solidFill>
                 <a:latin typeface="Montserrat"/>
               </a:rPr>
-              <a:t>En el jardín toda la familia puede visitarlas, quedan protegidas ante mudanzas o cambios, y tienen un lugar con su nombre.</a:t>
+              <a:t>En el jardín o en el columbario toda la familia puede visitarlas, quedan protegidas ante mudanzas o cambios, y tienen un lugar con su nombre.</a:t>
             </a:r>
           </a:p>
         </p:txBody>
@@ -35451,7 +35451,7 @@
                 </a:solidFill>
                 <a:latin typeface="Montserrat"/>
               </a:rPr>
-              <a:t>"¿Le gustaría visitar el jardín antes de decidir?"</a:t>
+              <a:t>"¿Le gustaría visitar el jardín o el columbario antes de decidir?"</a:t>
             </a:r>
           </a:p>
         </p:txBody>
@@ -36475,7 +36475,7 @@
                 </a:solidFill>
                 <a:latin typeface="Montserrat"/>
               </a:rPr>
-              <a:t>Somos La Auxiliadora, Hogar de las Memorias y Las Colinas, empresas de Vangrupo con trayectoria en El Salvador. El contrato es transparente y puede visitar el jardín cuando quiera.</a:t>
+              <a:t>Somos La Auxiliadora, Hogar de las Memorias y Las Colinas, empresas de Vangrupo con trayectoria en El Salvador. El contrato es transparente y puede visitar el jardín o el columbario cuando quiera.</a:t>
             </a:r>
           </a:p>
         </p:txBody>
@@ -43056,7 +43056,7 @@
                 </a:solidFill>
                 <a:latin typeface="Montserrat"/>
               </a:rPr>
-              <a:t>Visita al jardín</a:t>
+              <a:t>Visita al jardín o al columbario</a:t>
             </a:r>
           </a:p>
           <a:p>
@@ -43687,7 +43687,7 @@
                 </a:solidFill>
                 <a:latin typeface="Montserrat"/>
               </a:rPr>
-              <a:t>Expliqué la cuota de mantenimiento y el plazo (30 años renovables o 3 años), según el caso.</a:t>
+              <a:t>Expliqué la cuota de mantenimiento y el plazo (30 años renovables o 3 años) o, en columbarios, la ubicación (definida o a futuro).</a:t>
             </a:r>
           </a:p>
           <a:p>
@@ -44665,7 +44665,7 @@
                 </a:solidFill>
                 <a:latin typeface="Playfair Display"/>
               </a:rPr>
-              <a:t>Qué producto lleva cada equipo</a:t>
+              <a:t>Equipos de venta</a:t>
             </a:r>
           </a:p>
         </p:txBody>
@@ -44679,7 +44679,7 @@
         <p:spPr>
           <a:xfrm>
             <a:off x="548640" y="4800600"/>
-            <a:ext cx="3566160" cy="1417320"/>
+            <a:ext cx="3566160" cy="1005840"/>
           </a:xfrm>
           <a:prstGeom prst="rect">
             <a:avLst/>
@@ -44723,7 +44723,7 @@
         <p:spPr>
           <a:xfrm>
             <a:off x="685800" y="4864608"/>
-            <a:ext cx="3291840" cy="1325880"/>
+            <a:ext cx="3291840" cy="914400"/>
           </a:xfrm>
           <a:prstGeom prst="rect">
             <a:avLst/>
@@ -44770,7 +44770,7 @@
                 </a:solidFill>
                 <a:latin typeface="Montserrat"/>
               </a:rPr>
-              <a:t>Jardín Individual y Ecológico como destino de las cenizas; Solución Modular para el resto de la familia (venta de prenecesidad posterior).</a:t>
+              <a:t>Acompaña a la familia durante el servicio y trabaja referidos.</a:t>
             </a:r>
           </a:p>
         </p:txBody>
@@ -44784,7 +44784,7 @@
         <p:spPr>
           <a:xfrm>
             <a:off x="4297680" y="4800600"/>
-            <a:ext cx="3566160" cy="1417320"/>
+            <a:ext cx="3566160" cy="1005840"/>
           </a:xfrm>
           <a:prstGeom prst="rect">
             <a:avLst/>
@@ -44828,7 +44828,7 @@
         <p:spPr>
           <a:xfrm>
             <a:off x="4434840" y="4864608"/>
-            <a:ext cx="3291840" cy="1325880"/>
+            <a:ext cx="3291840" cy="914400"/>
           </a:xfrm>
           <a:prstGeom prst="rect">
             <a:avLst/>
@@ -44875,7 +44875,7 @@
                 </a:solidFill>
                 <a:latin typeface="Montserrat"/>
               </a:rPr>
-              <a:t>Solución Modular (cuota baja, fácil de explicar) y Jardín de Mascotas.</a:t>
+              <a:t>Eventos, centros comerciales, bases de cancelaciones y telemercadeo.</a:t>
             </a:r>
           </a:p>
         </p:txBody>
@@ -44889,7 +44889,7 @@
         <p:spPr>
           <a:xfrm>
             <a:off x="8046720" y="4800600"/>
-            <a:ext cx="3566160" cy="1417320"/>
+            <a:ext cx="3566160" cy="1005840"/>
           </a:xfrm>
           <a:prstGeom prst="rect">
             <a:avLst/>
@@ -44933,7 +44933,7 @@
         <p:spPr>
           <a:xfrm>
             <a:off x="8183880" y="4864608"/>
-            <a:ext cx="3291840" cy="1325880"/>
+            <a:ext cx="3291840" cy="914400"/>
           </a:xfrm>
           <a:prstGeom prst="rect">
             <a:avLst/>
@@ -44980,7 +44980,7 @@
                 </a:solidFill>
                 <a:latin typeface="Montserrat"/>
               </a:rPr>
-              <a:t>Solución Modular + Jardín Individual: la combinación más completa para el hogar.</a:t>
+              <a:t>Prospección sistemática en colonias.</a:t>
             </a:r>
           </a:p>
         </p:txBody>
@@ -44988,6 +44988,48 @@
       <p:sp>
         <p:nvSpPr>
           <p:cNvPr id="21" name="TextBox 20"/>
+          <p:cNvSpPr txBox="1"/>
+          <p:nvPr/>
+        </p:nvSpPr>
+        <p:spPr>
+          <a:xfrm>
+            <a:off x="548640" y="5897880"/>
+            <a:ext cx="11094415" cy="411480"/>
+          </a:xfrm>
+          <a:prstGeom prst="rect">
+            <a:avLst/>
+          </a:prstGeom>
+          <a:noFill/>
+        </p:spPr>
+        <p:txBody>
+          <a:bodyPr wrap="square" anchor="t" lIns="45720" rIns="45720" tIns="27432" bIns="27432">
+            <a:spAutoFit/>
+          </a:bodyPr>
+          <a:lstStyle/>
+          <a:p>
+            <a:pPr algn="l">
+              <a:lnSpc>
+                <a:spcPct val="115000"/>
+              </a:lnSpc>
+              <a:spcAft>
+                <a:spcPts val="400"/>
+              </a:spcAft>
+            </a:pPr>
+            <a:r>
+              <a:rPr sz="1100" b="0" i="1">
+                <a:solidFill>
+                  <a:srgbClr val="7D7887"/>
+                </a:solidFill>
+                <a:latin typeface="Montserrat"/>
+              </a:rPr>
+              <a:t>Todos los equipos venden todo el portafolio de cremación (Solución Modular, jardines de cenizas y columbarios), con la misma política de comisiones.</a:t>
+            </a:r>
+          </a:p>
+        </p:txBody>
+      </p:sp>
+      <p:sp>
+        <p:nvSpPr>
+          <p:cNvPr id="22" name="TextBox 21"/>
           <p:cNvSpPr txBox="1"/>
           <p:nvPr/>
         </p:nvSpPr>
@@ -45029,7 +45071,7 @@
       </p:sp>
       <p:sp>
         <p:nvSpPr>
-          <p:cNvPr id="22" name="TextBox 21"/>
+          <p:cNvPr id="23" name="TextBox 22"/>
           <p:cNvSpPr txBox="1"/>
           <p:nvPr/>
         </p:nvSpPr>
@@ -45840,7 +45882,7 @@
                 </a:solidFill>
                 <a:latin typeface="Montserrat"/>
               </a:rPr>
-              <a:t>Solución Modular · Jardín Individual · Jardín Familiar</a:t>
+              <a:t>Solución Modular · Jardín Individual o Familiar · Columbario Mármol o Cristal, Ónix u Obra de Arte</a:t>
             </a:r>
           </a:p>
         </p:txBody>
@@ -46096,7 +46138,7 @@
                 </a:solidFill>
                 <a:latin typeface="Montserrat"/>
               </a:rPr>
-              <a:t>Solución Modular · Jardín Familiar</a:t>
+              <a:t>Solución Modular · Jardín Familiar · Columbario Supremo Plus</a:t>
             </a:r>
           </a:p>
         </p:txBody>
@@ -46352,7 +46394,7 @@
                 </a:solidFill>
                 <a:latin typeface="Montserrat"/>
               </a:rPr>
-              <a:t>Jardín Individual · Jardín Ecológico</a:t>
+              <a:t>Supremo Plus o Bella Vista (incluyen la cremación) · Jardín Individual o Ecológico</a:t>
             </a:r>
           </a:p>
         </p:txBody>

</xml_diff>

<commit_message>
Playbook: figura del portafolio con lanzamientos y columbarios
Co-Authored-By: Claude Opus 5.5 <noreply@anthropic.com>
Claude-Session: https://claude.ai/code/session_0111i7vn9WWo4QxCQbucWbrF
</commit_message>
<xml_diff>
--- a/playbook/salida/Playbook_Comercial_Cremacion_Vangrupo.pptx
+++ b/playbook/salida/Playbook_Comercial_Cremacion_Vangrupo.pptx
@@ -42492,8 +42492,8 @@
         </p:blipFill>
         <p:spPr>
           <a:xfrm>
-            <a:off x="836994" y="1508760"/>
-            <a:ext cx="10517706" cy="4754880"/>
+            <a:off x="548640" y="1684652"/>
+            <a:ext cx="11094415" cy="4403095"/>
           </a:xfrm>
           <a:prstGeom prst="rect">
             <a:avLst/>

</xml_diff>